<commit_message>
Redesign timeline slide; remove all slide footers
- Timeline: new horizontal 4-card layout with connector line and
  numbered nodes; weeks-only labels (no dates); AHEAD/EXPANDED badges
  on bottom actual-cards; Week 4 card inverted (black) to stand out
- Removed all footer bars with name/email/group from every slide
- Dropped Thank You slide (redundant for copy-paste use)
- 8 slides total

Co-Authored-By: Claude Sonnet 4.6 <noreply@anthropic.com>
</commit_message>
<xml_diff>
--- a/thomas_presentation.pptx
+++ b/thomas_presentation.pptx
@@ -13,10 +13,9 @@
     <p:sldId id="261" r:id="rId7"/>
     <p:sldId id="262" r:id="rId8"/>
     <p:sldId id="263" r:id="rId9"/>
-    <p:sldId id="264" r:id="rId10"/>
   </p:sldIdLst>
   <p:notesMasterIdLst>
-    <p:notesMasterId r:id="rId11"/>
+    <p:notesMasterId r:id="rId10"/>
   </p:notesMasterIdLst>
   <p:sldSz cx="9144000" cy="5143500"/>
   <p:notesSz cx="5143500" cy="9144000"/>
@@ -1150,94 +1149,6 @@
             <a:fld id="{F7021451-1387-4CA6-816F-3879F97B5CBC}" type="slidenum">
               <a:rPr lang="en-US"/>
               <a:t>8</a:t>
-            </a:fld>
-            <a:endParaRPr lang="en-US"/>
-          </a:p>
-        </p:txBody>
-      </p:sp>
-    </p:spTree>
-    <p:extLst>
-      <p:ext uri="{BB962C8B-B14F-4D97-AF65-F5344CB8AC3E}">
-        <p14:creationId xmlns:p14="http://schemas.microsoft.com/office/powerpoint/2010/main" val="1024086991"/>
-      </p:ext>
-    </p:extLst>
-  </p:cSld>
-  <p:clrMapOvr>
-    <a:masterClrMapping/>
-  </p:clrMapOvr>
-</p:notes>
-</file>
-
-<file path=ppt/notesSlides/notesSlide9.xml><?xml version="1.0" encoding="utf-8"?>
-<p:notes xmlns:a="http://schemas.openxmlformats.org/drawingml/2006/main" xmlns:r="http://schemas.openxmlformats.org/officeDocument/2006/relationships" xmlns:p="http://schemas.openxmlformats.org/presentationml/2006/main">
-  <p:cSld>
-    <p:spTree>
-      <p:nvGrpSpPr>
-        <p:cNvPr id="1" name=""/>
-        <p:cNvGrpSpPr/>
-        <p:nvPr/>
-      </p:nvGrpSpPr>
-      <p:grpSpPr>
-        <a:xfrm>
-          <a:off x="0" y="0"/>
-          <a:ext cx="0" cy="0"/>
-          <a:chOff x="0" y="0"/>
-          <a:chExt cx="0" cy="0"/>
-        </a:xfrm>
-      </p:grpSpPr>
-      <p:sp>
-        <p:nvSpPr>
-          <p:cNvPr id="2" name="Slide Image Placeholder 1"/>
-          <p:cNvSpPr>
-            <a:spLocks noGrp="1" noRot="1" noChangeAspect="1"/>
-          </p:cNvSpPr>
-          <p:nvPr>
-            <p:ph type="sldImg"/>
-          </p:nvPr>
-        </p:nvSpPr>
-        <p:spPr/>
-      </p:sp>
-      <p:sp>
-        <p:nvSpPr>
-          <p:cNvPr id="3" name="Notes Placeholder 2"/>
-          <p:cNvSpPr>
-            <a:spLocks noGrp="1"/>
-          </p:cNvSpPr>
-          <p:nvPr>
-            <p:ph type="body" idx="1"/>
-          </p:nvPr>
-        </p:nvSpPr>
-        <p:spPr/>
-        <p:txBody>
-          <a:bodyPr/>
-          <a:lstStyle/>
-          <a:p>
-            <a:r>
-              <a:rPr lang="en-US" dirty="0"/>
-              <a:t/>
-            </a:r>
-            <a:endParaRPr lang="en-US" dirty="0"/>
-          </a:p>
-        </p:txBody>
-      </p:sp>
-      <p:sp>
-        <p:nvSpPr>
-          <p:cNvPr id="4" name="Slide Number Placeholder 3"/>
-          <p:cNvSpPr>
-            <a:spLocks noGrp="1"/>
-          </p:cNvSpPr>
-          <p:nvPr>
-            <p:ph type="sldNum" sz="quarter" idx="10"/>
-          </p:nvPr>
-        </p:nvSpPr>
-        <p:spPr/>
-        <p:txBody>
-          <a:bodyPr/>
-          <a:lstStyle/>
-          <a:p>
-            <a:fld id="{F7021451-1387-4CA6-816F-3879F97B5CBC}" type="slidenum">
-              <a:rPr lang="en-US"/>
-              <a:t>9</a:t>
             </a:fld>
             <a:endParaRPr lang="en-US"/>
           </a:p>
@@ -1676,103 +1587,31 @@
         </p:nvSpPr>
         <p:spPr>
           <a:xfrm>
-            <a:off x="457200" y="4297680"/>
-            <a:ext cx="2743200" cy="365760"/>
-          </a:xfrm>
-          <a:prstGeom prst="rect">
-            <a:avLst/>
-          </a:prstGeom>
-          <a:noFill/>
-          <a:ln/>
-        </p:spPr>
-        <p:txBody>
-          <a:bodyPr wrap="square" lIns="0" tIns="0" rIns="0" bIns="0" rtlCol="0" anchor="ctr"/>
-          <a:lstStyle/>
-          <a:p>
-            <a:pPr algn="l" indent="0" marL="0">
-              <a:buNone/>
-            </a:pPr>
-            <a:r>
-              <a:rPr lang="en-US" sz="1400" b="1" dirty="0">
-                <a:solidFill>
-                  <a:srgbClr val="FFFFFF"/>
-                </a:solidFill>
-              </a:rPr>
-              <a:t>Group 2</a:t>
-            </a:r>
-            <a:endParaRPr lang="en-US" sz="1400" dirty="0"/>
-          </a:p>
-        </p:txBody>
-      </p:sp>
-      <p:sp>
-        <p:nvSpPr>
-          <p:cNvPr id="5" name="Text 3"/>
-          <p:cNvSpPr/>
-          <p:nvPr/>
-        </p:nvSpPr>
-        <p:spPr>
-          <a:xfrm>
-            <a:off x="457200" y="4663440"/>
-            <a:ext cx="5486400" cy="274320"/>
-          </a:xfrm>
-          <a:prstGeom prst="rect">
-            <a:avLst/>
-          </a:prstGeom>
-          <a:noFill/>
-          <a:ln/>
-        </p:spPr>
-        <p:txBody>
-          <a:bodyPr wrap="square" lIns="0" tIns="0" rIns="0" bIns="0" rtlCol="0" anchor="ctr"/>
-          <a:lstStyle/>
-          <a:p>
-            <a:pPr algn="l" indent="0" marL="0">
-              <a:buNone/>
-            </a:pPr>
-            <a:r>
-              <a:rPr lang="en-US" sz="1100" dirty="0">
+            <a:off x="457200" y="4315968"/>
+            <a:ext cx="8229600" cy="777240"/>
+          </a:xfrm>
+          <a:prstGeom prst="rect">
+            <a:avLst/>
+          </a:prstGeom>
+          <a:noFill/>
+          <a:ln/>
+        </p:spPr>
+        <p:txBody>
+          <a:bodyPr wrap="square" lIns="0" tIns="0" rIns="0" bIns="0" rtlCol="0" anchor="ctr"/>
+          <a:lstStyle/>
+          <a:p>
+            <a:pPr algn="ctr" indent="0" marL="0">
+              <a:buNone/>
+            </a:pPr>
+            <a:r>
+              <a:rPr lang="en-US" sz="1300" dirty="0">
                 <a:solidFill>
                   <a:srgbClr val="BBBBBB"/>
                 </a:solidFill>
               </a:rPr>
-              <a:t>Ming-Hsiang Lee  (lee.minghsi@northeastern.edu)</a:t>
-            </a:r>
-            <a:endParaRPr lang="en-US" sz="1100" dirty="0"/>
-          </a:p>
-        </p:txBody>
-      </p:sp>
-      <p:sp>
-        <p:nvSpPr>
-          <p:cNvPr id="6" name="Text 4"/>
-          <p:cNvSpPr/>
-          <p:nvPr/>
-        </p:nvSpPr>
-        <p:spPr>
-          <a:xfrm>
-            <a:off x="5029200" y="4315968"/>
-            <a:ext cx="3840480" cy="777240"/>
-          </a:xfrm>
-          <a:prstGeom prst="rect">
-            <a:avLst/>
-          </a:prstGeom>
-          <a:noFill/>
-          <a:ln/>
-        </p:spPr>
-        <p:txBody>
-          <a:bodyPr wrap="square" lIns="0" tIns="0" rIns="0" bIns="0" rtlCol="0" anchor="ctr"/>
-          <a:lstStyle/>
-          <a:p>
-            <a:pPr algn="r" indent="0" marL="0">
-              <a:buNone/>
-            </a:pPr>
-            <a:r>
-              <a:rPr lang="en-US" sz="1100" dirty="0">
-                <a:solidFill>
-                  <a:srgbClr val="BBBBBB"/>
-                </a:solidFill>
-              </a:rPr>
               <a:t>Data Download  ·  Preprocessing  ·  Dataset Migration</a:t>
             </a:r>
-            <a:endParaRPr lang="en-US" sz="1100" dirty="0"/>
+            <a:endParaRPr lang="en-US" sz="1300" dirty="0"/>
           </a:p>
         </p:txBody>
       </p:sp>
@@ -1965,9 +1804,6 @@
                 <a:solidFill>
                   <a:srgbClr val="1A1A1A"/>
                 </a:solidFill>
-                <a:latin typeface="Arial" pitchFamily="34" charset="0"/>
-                <a:ea typeface="Arial" pitchFamily="34" charset="-122"/>
-                <a:cs typeface="Arial" pitchFamily="34" charset="-120"/>
               </a:rPr>
               <a:t>Data Download</a:t>
             </a:r>
@@ -2168,9 +2004,6 @@
                 <a:solidFill>
                   <a:srgbClr val="1A1A1A"/>
                 </a:solidFill>
-                <a:latin typeface="Arial" pitchFamily="34" charset="0"/>
-                <a:ea typeface="Arial" pitchFamily="34" charset="-122"/>
-                <a:cs typeface="Arial" pitchFamily="34" charset="-120"/>
               </a:rPr>
               <a:t>Data Preprocessing</a:t>
             </a:r>
@@ -2371,9 +2204,6 @@
                 <a:solidFill>
                   <a:srgbClr val="1A1A1A"/>
                 </a:solidFill>
-                <a:latin typeface="Arial" pitchFamily="34" charset="0"/>
-                <a:ea typeface="Arial" pitchFamily="34" charset="-122"/>
-                <a:cs typeface="Arial" pitchFamily="34" charset="-120"/>
               </a:rPr>
               <a:t>Dataset Migration</a:t>
             </a:r>
@@ -2574,9 +2404,6 @@
                 <a:solidFill>
                   <a:srgbClr val="1A1A1A"/>
                 </a:solidFill>
-                <a:latin typeface="Arial" pitchFamily="34" charset="0"/>
-                <a:ea typeface="Arial" pitchFamily="34" charset="-122"/>
-                <a:cs typeface="Arial" pitchFamily="34" charset="-120"/>
               </a:rPr>
               <a:t>Team Infrastructure</a:t>
             </a:r>
@@ -2654,67 +2481,6 @@
                 <a:cs typeface="Consolas" pitchFamily="34" charset="-120"/>
               </a:rPr>
               <a:t>data/  ·  README.md</a:t>
-            </a:r>
-            <a:endParaRPr lang="en-US" sz="900" dirty="0"/>
-          </a:p>
-        </p:txBody>
-      </p:sp>
-      <p:sp>
-        <p:nvSpPr>
-          <p:cNvPr id="27" name="Shape 25"/>
-          <p:cNvSpPr/>
-          <p:nvPr/>
-        </p:nvSpPr>
-        <p:spPr>
-          <a:xfrm>
-            <a:off x="0" y="4818888"/>
-            <a:ext cx="9144000" cy="324612"/>
-          </a:xfrm>
-          <a:prstGeom prst="rect">
-            <a:avLst/>
-          </a:prstGeom>
-          <a:solidFill>
-            <a:srgbClr val="1A1A1A"/>
-          </a:solidFill>
-          <a:ln w="12700">
-            <a:solidFill>
-              <a:srgbClr val="1A1A1A"/>
-            </a:solidFill>
-            <a:prstDash val="solid"/>
-          </a:ln>
-        </p:spPr>
-      </p:sp>
-      <p:sp>
-        <p:nvSpPr>
-          <p:cNvPr id="28" name="Text 26"/>
-          <p:cNvSpPr/>
-          <p:nvPr/>
-        </p:nvSpPr>
-        <p:spPr>
-          <a:xfrm>
-            <a:off x="274320" y="4828032"/>
-            <a:ext cx="8595360" cy="301752"/>
-          </a:xfrm>
-          <a:prstGeom prst="rect">
-            <a:avLst/>
-          </a:prstGeom>
-          <a:noFill/>
-          <a:ln/>
-        </p:spPr>
-        <p:txBody>
-          <a:bodyPr wrap="square" lIns="0" tIns="0" rIns="0" bIns="0" rtlCol="0" anchor="ctr"/>
-          <a:lstStyle/>
-          <a:p>
-            <a:pPr algn="l" indent="0" marL="0">
-              <a:buNone/>
-            </a:pPr>
-            <a:r>
-              <a:rPr lang="en-US" sz="900" dirty="0">
-                <a:solidFill>
-                  <a:srgbClr val="AAAAAA"/>
-                </a:solidFill>
-              </a:rPr>
-              <a:t>Ming-Hsiang Lee  ·  Data Pipeline &amp; Preprocessing  ·  News Topic Classification  ·  Group 2</a:t>
             </a:r>
             <a:endParaRPr lang="en-US" sz="900" dirty="0"/>
           </a:p>
@@ -2760,8 +2526,8 @@
         </p:nvSpPr>
         <p:spPr>
           <a:xfrm>
-            <a:off x="457200" y="201168"/>
-            <a:ext cx="8229600" cy="594360"/>
+            <a:off x="457200" y="182880"/>
+            <a:ext cx="8229600" cy="548640"/>
           </a:xfrm>
           <a:prstGeom prst="rect">
             <a:avLst/>
@@ -2793,14 +2559,1061 @@
       </p:sp>
       <p:sp>
         <p:nvSpPr>
-          <p:cNvPr id="3" name="Shape 1"/>
-          <p:cNvSpPr/>
-          <p:nvPr/>
-        </p:nvSpPr>
-        <p:spPr>
-          <a:xfrm>
-            <a:off x="457200" y="868680"/>
-            <a:ext cx="1508760" cy="347472"/>
+          <p:cNvPr id="3" name="Text 1"/>
+          <p:cNvSpPr/>
+          <p:nvPr/>
+        </p:nvSpPr>
+        <p:spPr>
+          <a:xfrm>
+            <a:off x="457200" y="804672"/>
+            <a:ext cx="4114800" cy="256032"/>
+          </a:xfrm>
+          <a:prstGeom prst="rect">
+            <a:avLst/>
+          </a:prstGeom>
+          <a:noFill/>
+          <a:ln/>
+        </p:spPr>
+        <p:txBody>
+          <a:bodyPr wrap="square" lIns="0" tIns="0" rIns="0" bIns="0" rtlCol="0" anchor="ctr"/>
+          <a:lstStyle/>
+          <a:p>
+            <a:pPr algn="l" indent="0" marL="0">
+              <a:buNone/>
+            </a:pPr>
+            <a:r>
+              <a:rPr lang="en-US" sz="1000" i="1" dirty="0">
+                <a:solidFill>
+                  <a:srgbClr val="888888"/>
+                </a:solidFill>
+              </a:rPr>
+              <a:t>Planned</a:t>
+            </a:r>
+            <a:endParaRPr lang="en-US" sz="1000" dirty="0"/>
+          </a:p>
+        </p:txBody>
+      </p:sp>
+      <p:sp>
+        <p:nvSpPr>
+          <p:cNvPr id="4" name="Text 2"/>
+          <p:cNvSpPr/>
+          <p:nvPr/>
+        </p:nvSpPr>
+        <p:spPr>
+          <a:xfrm>
+            <a:off x="4663440" y="804672"/>
+            <a:ext cx="4023360" cy="256032"/>
+          </a:xfrm>
+          <a:prstGeom prst="rect">
+            <a:avLst/>
+          </a:prstGeom>
+          <a:noFill/>
+          <a:ln/>
+        </p:spPr>
+        <p:txBody>
+          <a:bodyPr wrap="square" lIns="0" tIns="0" rIns="0" bIns="0" rtlCol="0" anchor="ctr"/>
+          <a:lstStyle/>
+          <a:p>
+            <a:pPr algn="l" indent="0" marL="0">
+              <a:buNone/>
+            </a:pPr>
+            <a:r>
+              <a:rPr lang="en-US" sz="1000" i="1" dirty="0">
+                <a:solidFill>
+                  <a:srgbClr val="888888"/>
+                </a:solidFill>
+              </a:rPr>
+              <a:t>What actually happened</a:t>
+            </a:r>
+            <a:endParaRPr lang="en-US" sz="1000" dirty="0"/>
+          </a:p>
+        </p:txBody>
+      </p:sp>
+      <p:sp>
+        <p:nvSpPr>
+          <p:cNvPr id="5" name="Shape 3"/>
+          <p:cNvSpPr/>
+          <p:nvPr/>
+        </p:nvSpPr>
+        <p:spPr>
+          <a:xfrm>
+            <a:off x="960120" y="1664208"/>
+            <a:ext cx="7223760" cy="0"/>
+          </a:xfrm>
+          <a:prstGeom prst="line">
+            <a:avLst/>
+          </a:prstGeom>
+          <a:noFill/>
+          <a:ln w="25400">
+            <a:solidFill>
+              <a:srgbClr val="D8D0C0"/>
+            </a:solidFill>
+            <a:prstDash val="solid"/>
+          </a:ln>
+        </p:spPr>
+      </p:sp>
+      <p:sp>
+        <p:nvSpPr>
+          <p:cNvPr id="6" name="Shape 4"/>
+          <p:cNvSpPr/>
+          <p:nvPr/>
+        </p:nvSpPr>
+        <p:spPr>
+          <a:xfrm>
+            <a:off x="658368" y="1097280"/>
+            <a:ext cx="1901952" cy="868680"/>
+          </a:xfrm>
+          <a:prstGeom prst="rect">
+            <a:avLst/>
+          </a:prstGeom>
+          <a:solidFill>
+            <a:srgbClr val="FAF7F2"/>
+          </a:solidFill>
+          <a:ln w="12700">
+            <a:solidFill>
+              <a:srgbClr val="D8D0C0"/>
+            </a:solidFill>
+            <a:prstDash val="solid"/>
+          </a:ln>
+        </p:spPr>
+      </p:sp>
+      <p:sp>
+        <p:nvSpPr>
+          <p:cNvPr id="7" name="Text 5"/>
+          <p:cNvSpPr/>
+          <p:nvPr/>
+        </p:nvSpPr>
+        <p:spPr>
+          <a:xfrm>
+            <a:off x="749808" y="1124712"/>
+            <a:ext cx="1719072" cy="228600"/>
+          </a:xfrm>
+          <a:prstGeom prst="rect">
+            <a:avLst/>
+          </a:prstGeom>
+          <a:noFill/>
+          <a:ln/>
+        </p:spPr>
+        <p:txBody>
+          <a:bodyPr wrap="square" lIns="0" tIns="0" rIns="0" bIns="0" rtlCol="0" anchor="ctr"/>
+          <a:lstStyle/>
+          <a:p>
+            <a:pPr indent="0" marL="0">
+              <a:buNone/>
+            </a:pPr>
+            <a:r>
+              <a:rPr lang="en-US" sz="1100" b="1" dirty="0">
+                <a:solidFill>
+                  <a:srgbClr val="1A1A1A"/>
+                </a:solidFill>
+              </a:rPr>
+              <a:t>Week 1</a:t>
+            </a:r>
+            <a:endParaRPr lang="en-US" sz="1100" dirty="0"/>
+          </a:p>
+        </p:txBody>
+      </p:sp>
+      <p:sp>
+        <p:nvSpPr>
+          <p:cNvPr id="8" name="Text 6"/>
+          <p:cNvSpPr/>
+          <p:nvPr/>
+        </p:nvSpPr>
+        <p:spPr>
+          <a:xfrm>
+            <a:off x="749808" y="1344168"/>
+            <a:ext cx="1719072" cy="566928"/>
+          </a:xfrm>
+          <a:prstGeom prst="rect">
+            <a:avLst/>
+          </a:prstGeom>
+          <a:noFill/>
+          <a:ln/>
+        </p:spPr>
+        <p:txBody>
+          <a:bodyPr wrap="square" lIns="0" tIns="0" rIns="0" bIns="0" rtlCol="0" anchor="ctr"/>
+          <a:lstStyle/>
+          <a:p>
+            <a:pPr indent="0" marL="0">
+              <a:buNone/>
+            </a:pPr>
+            <a:r>
+              <a:rPr lang="en-US" sz="950" dirty="0">
+                <a:solidFill>
+                  <a:srgbClr val="4A4A4A"/>
+                </a:solidFill>
+              </a:rPr>
+              <a:t>Finalize dataset</a:t>
+            </a:r>
+            <a:endParaRPr lang="en-US" sz="950" dirty="0"/>
+          </a:p>
+          <a:p>
+            <a:pPr indent="0" marL="0">
+              <a:buNone/>
+            </a:pPr>
+            <a:r>
+              <a:rPr lang="en-US" sz="950" dirty="0">
+                <a:solidFill>
+                  <a:srgbClr val="4A4A4A"/>
+                </a:solidFill>
+              </a:rPr>
+              <a:t>&amp; preprocessing</a:t>
+            </a:r>
+            <a:endParaRPr lang="en-US" sz="950" dirty="0"/>
+          </a:p>
+        </p:txBody>
+      </p:sp>
+      <p:sp>
+        <p:nvSpPr>
+          <p:cNvPr id="9" name="Shape 7"/>
+          <p:cNvSpPr/>
+          <p:nvPr/>
+        </p:nvSpPr>
+        <p:spPr>
+          <a:xfrm>
+            <a:off x="1408176" y="1463040"/>
+            <a:ext cx="402336" cy="402336"/>
+          </a:xfrm>
+          <a:prstGeom prst="ellipse">
+            <a:avLst/>
+          </a:prstGeom>
+          <a:solidFill>
+            <a:srgbClr val="FFFFFF"/>
+          </a:solidFill>
+          <a:ln w="25400">
+            <a:solidFill>
+              <a:srgbClr val="1A1A1A"/>
+            </a:solidFill>
+            <a:prstDash val="solid"/>
+          </a:ln>
+        </p:spPr>
+      </p:sp>
+      <p:sp>
+        <p:nvSpPr>
+          <p:cNvPr id="10" name="Text 8"/>
+          <p:cNvSpPr/>
+          <p:nvPr/>
+        </p:nvSpPr>
+        <p:spPr>
+          <a:xfrm>
+            <a:off x="1408176" y="1463040"/>
+            <a:ext cx="402336" cy="402336"/>
+          </a:xfrm>
+          <a:prstGeom prst="rect">
+            <a:avLst/>
+          </a:prstGeom>
+          <a:noFill/>
+          <a:ln/>
+        </p:spPr>
+        <p:txBody>
+          <a:bodyPr wrap="square" lIns="0" tIns="0" rIns="0" bIns="0" rtlCol="0" anchor="ctr"/>
+          <a:lstStyle/>
+          <a:p>
+            <a:pPr algn="ctr" indent="0" marL="0">
+              <a:buNone/>
+            </a:pPr>
+            <a:r>
+              <a:rPr lang="en-US" sz="1000" b="1" dirty="0">
+                <a:solidFill>
+                  <a:srgbClr val="1A1A1A"/>
+                </a:solidFill>
+              </a:rPr>
+              <a:t>1</a:t>
+            </a:r>
+            <a:endParaRPr lang="en-US" sz="1000" dirty="0"/>
+          </a:p>
+        </p:txBody>
+      </p:sp>
+      <p:sp>
+        <p:nvSpPr>
+          <p:cNvPr id="11" name="Shape 9"/>
+          <p:cNvSpPr/>
+          <p:nvPr/>
+        </p:nvSpPr>
+        <p:spPr>
+          <a:xfrm>
+            <a:off x="658368" y="1975104"/>
+            <a:ext cx="1901952" cy="2825496"/>
+          </a:xfrm>
+          <a:prstGeom prst="rect">
+            <a:avLst/>
+          </a:prstGeom>
+          <a:solidFill>
+            <a:srgbClr val="FAF7F2"/>
+          </a:solidFill>
+          <a:ln w="12700">
+            <a:solidFill>
+              <a:srgbClr val="D8D0C0"/>
+            </a:solidFill>
+            <a:prstDash val="solid"/>
+          </a:ln>
+        </p:spPr>
+      </p:sp>
+      <p:sp>
+        <p:nvSpPr>
+          <p:cNvPr id="12" name="Text 10"/>
+          <p:cNvSpPr/>
+          <p:nvPr/>
+        </p:nvSpPr>
+        <p:spPr>
+          <a:xfrm>
+            <a:off x="749808" y="2066544"/>
+            <a:ext cx="1719072" cy="320040"/>
+          </a:xfrm>
+          <a:prstGeom prst="rect">
+            <a:avLst/>
+          </a:prstGeom>
+          <a:noFill/>
+          <a:ln/>
+        </p:spPr>
+        <p:txBody>
+          <a:bodyPr wrap="square" lIns="0" tIns="0" rIns="0" bIns="0" rtlCol="0" anchor="ctr"/>
+          <a:lstStyle/>
+          <a:p>
+            <a:pPr indent="0" marL="0">
+              <a:buNone/>
+            </a:pPr>
+            <a:r>
+              <a:rPr lang="en-US" sz="1100" b="1" dirty="0">
+                <a:solidFill>
+                  <a:srgbClr val="1A1A1A"/>
+                </a:solidFill>
+              </a:rPr>
+              <a:t>BBC News pipeline done</a:t>
+            </a:r>
+            <a:endParaRPr lang="en-US" sz="1100" dirty="0"/>
+          </a:p>
+        </p:txBody>
+      </p:sp>
+      <p:sp>
+        <p:nvSpPr>
+          <p:cNvPr id="13" name="Text 11"/>
+          <p:cNvSpPr/>
+          <p:nvPr/>
+        </p:nvSpPr>
+        <p:spPr>
+          <a:xfrm>
+            <a:off x="749808" y="2414016"/>
+            <a:ext cx="1719072" cy="2350008"/>
+          </a:xfrm>
+          <a:prstGeom prst="rect">
+            <a:avLst/>
+          </a:prstGeom>
+          <a:noFill/>
+          <a:ln/>
+        </p:spPr>
+        <p:txBody>
+          <a:bodyPr wrap="square" lIns="0" tIns="0" rIns="0" bIns="0" rtlCol="0" anchor="ctr"/>
+          <a:lstStyle/>
+          <a:p>
+            <a:pPr indent="0" marL="0">
+              <a:buNone/>
+            </a:pPr>
+            <a:r>
+              <a:rPr lang="en-US" sz="950" dirty="0">
+                <a:solidFill>
+                  <a:srgbClr val="4A4A4A"/>
+                </a:solidFill>
+              </a:rPr>
+              <a:t>download_data.py +</a:t>
+            </a:r>
+            <a:endParaRPr lang="en-US" sz="950" dirty="0"/>
+          </a:p>
+          <a:p>
+            <a:pPr indent="0" marL="0">
+              <a:buNone/>
+            </a:pPr>
+            <a:r>
+              <a:rPr lang="en-US" sz="950" dirty="0">
+                <a:solidFill>
+                  <a:srgbClr val="4A4A4A"/>
+                </a:solidFill>
+              </a:rPr>
+              <a:t>data_preprocessing.py</a:t>
+            </a:r>
+            <a:endParaRPr lang="en-US" sz="950" dirty="0"/>
+          </a:p>
+          <a:p>
+            <a:pPr indent="0" marL="0">
+              <a:buNone/>
+            </a:pPr>
+            <a:r>
+              <a:rPr lang="en-US" sz="950" dirty="0">
+                <a:solidFill>
+                  <a:srgbClr val="4A4A4A"/>
+                </a:solidFill>
+              </a:rPr>
+              <a:t>All CSVs committed to repo</a:t>
+            </a:r>
+            <a:endParaRPr lang="en-US" sz="950" dirty="0"/>
+          </a:p>
+        </p:txBody>
+      </p:sp>
+      <p:sp>
+        <p:nvSpPr>
+          <p:cNvPr id="14" name="Shape 12"/>
+          <p:cNvSpPr/>
+          <p:nvPr/>
+        </p:nvSpPr>
+        <p:spPr>
+          <a:xfrm>
+            <a:off x="2633472" y="1097280"/>
+            <a:ext cx="1901952" cy="868680"/>
+          </a:xfrm>
+          <a:prstGeom prst="rect">
+            <a:avLst/>
+          </a:prstGeom>
+          <a:solidFill>
+            <a:srgbClr val="FAF7F2"/>
+          </a:solidFill>
+          <a:ln w="12700">
+            <a:solidFill>
+              <a:srgbClr val="D8D0C0"/>
+            </a:solidFill>
+            <a:prstDash val="solid"/>
+          </a:ln>
+        </p:spPr>
+      </p:sp>
+      <p:sp>
+        <p:nvSpPr>
+          <p:cNvPr id="15" name="Text 13"/>
+          <p:cNvSpPr/>
+          <p:nvPr/>
+        </p:nvSpPr>
+        <p:spPr>
+          <a:xfrm>
+            <a:off x="2724912" y="1124712"/>
+            <a:ext cx="1719072" cy="228600"/>
+          </a:xfrm>
+          <a:prstGeom prst="rect">
+            <a:avLst/>
+          </a:prstGeom>
+          <a:noFill/>
+          <a:ln/>
+        </p:spPr>
+        <p:txBody>
+          <a:bodyPr wrap="square" lIns="0" tIns="0" rIns="0" bIns="0" rtlCol="0" anchor="ctr"/>
+          <a:lstStyle/>
+          <a:p>
+            <a:pPr indent="0" marL="0">
+              <a:buNone/>
+            </a:pPr>
+            <a:r>
+              <a:rPr lang="en-US" sz="1100" b="1" dirty="0">
+                <a:solidFill>
+                  <a:srgbClr val="1A1A1A"/>
+                </a:solidFill>
+              </a:rPr>
+              <a:t>Week 2</a:t>
+            </a:r>
+            <a:endParaRPr lang="en-US" sz="1100" dirty="0"/>
+          </a:p>
+        </p:txBody>
+      </p:sp>
+      <p:sp>
+        <p:nvSpPr>
+          <p:cNvPr id="16" name="Text 14"/>
+          <p:cNvSpPr/>
+          <p:nvPr/>
+        </p:nvSpPr>
+        <p:spPr>
+          <a:xfrm>
+            <a:off x="2724912" y="1344168"/>
+            <a:ext cx="1719072" cy="566928"/>
+          </a:xfrm>
+          <a:prstGeom prst="rect">
+            <a:avLst/>
+          </a:prstGeom>
+          <a:noFill/>
+          <a:ln/>
+        </p:spPr>
+        <p:txBody>
+          <a:bodyPr wrap="square" lIns="0" tIns="0" rIns="0" bIns="0" rtlCol="0" anchor="ctr"/>
+          <a:lstStyle/>
+          <a:p>
+            <a:pPr indent="0" marL="0">
+              <a:buNone/>
+            </a:pPr>
+            <a:r>
+              <a:rPr lang="en-US" sz="950" dirty="0">
+                <a:solidFill>
+                  <a:srgbClr val="4A4A4A"/>
+                </a:solidFill>
+              </a:rPr>
+              <a:t>Baseline classifier</a:t>
+            </a:r>
+            <a:endParaRPr lang="en-US" sz="950" dirty="0"/>
+          </a:p>
+          <a:p>
+            <a:pPr indent="0" marL="0">
+              <a:buNone/>
+            </a:pPr>
+            <a:r>
+              <a:rPr lang="en-US" sz="950" dirty="0">
+                <a:solidFill>
+                  <a:srgbClr val="4A4A4A"/>
+                </a:solidFill>
+              </a:rPr>
+              <a:t>(n-gram + LR)</a:t>
+            </a:r>
+            <a:endParaRPr lang="en-US" sz="950" dirty="0"/>
+          </a:p>
+        </p:txBody>
+      </p:sp>
+      <p:sp>
+        <p:nvSpPr>
+          <p:cNvPr id="17" name="Shape 15"/>
+          <p:cNvSpPr/>
+          <p:nvPr/>
+        </p:nvSpPr>
+        <p:spPr>
+          <a:xfrm>
+            <a:off x="3383280" y="1463040"/>
+            <a:ext cx="402336" cy="402336"/>
+          </a:xfrm>
+          <a:prstGeom prst="ellipse">
+            <a:avLst/>
+          </a:prstGeom>
+          <a:solidFill>
+            <a:srgbClr val="FFFFFF"/>
+          </a:solidFill>
+          <a:ln w="25400">
+            <a:solidFill>
+              <a:srgbClr val="1A1A1A"/>
+            </a:solidFill>
+            <a:prstDash val="solid"/>
+          </a:ln>
+        </p:spPr>
+      </p:sp>
+      <p:sp>
+        <p:nvSpPr>
+          <p:cNvPr id="18" name="Text 16"/>
+          <p:cNvSpPr/>
+          <p:nvPr/>
+        </p:nvSpPr>
+        <p:spPr>
+          <a:xfrm>
+            <a:off x="3383280" y="1463040"/>
+            <a:ext cx="402336" cy="402336"/>
+          </a:xfrm>
+          <a:prstGeom prst="rect">
+            <a:avLst/>
+          </a:prstGeom>
+          <a:noFill/>
+          <a:ln/>
+        </p:spPr>
+        <p:txBody>
+          <a:bodyPr wrap="square" lIns="0" tIns="0" rIns="0" bIns="0" rtlCol="0" anchor="ctr"/>
+          <a:lstStyle/>
+          <a:p>
+            <a:pPr algn="ctr" indent="0" marL="0">
+              <a:buNone/>
+            </a:pPr>
+            <a:r>
+              <a:rPr lang="en-US" sz="1000" b="1" dirty="0">
+                <a:solidFill>
+                  <a:srgbClr val="1A1A1A"/>
+                </a:solidFill>
+              </a:rPr>
+              <a:t>2</a:t>
+            </a:r>
+            <a:endParaRPr lang="en-US" sz="1000" dirty="0"/>
+          </a:p>
+        </p:txBody>
+      </p:sp>
+      <p:sp>
+        <p:nvSpPr>
+          <p:cNvPr id="19" name="Shape 17"/>
+          <p:cNvSpPr/>
+          <p:nvPr/>
+        </p:nvSpPr>
+        <p:spPr>
+          <a:xfrm>
+            <a:off x="2633472" y="1975104"/>
+            <a:ext cx="1901952" cy="2825496"/>
+          </a:xfrm>
+          <a:prstGeom prst="rect">
+            <a:avLst/>
+          </a:prstGeom>
+          <a:solidFill>
+            <a:srgbClr val="FAF7F2"/>
+          </a:solidFill>
+          <a:ln w="12700">
+            <a:solidFill>
+              <a:srgbClr val="D8D0C0"/>
+            </a:solidFill>
+            <a:prstDash val="solid"/>
+          </a:ln>
+        </p:spPr>
+      </p:sp>
+      <p:sp>
+        <p:nvSpPr>
+          <p:cNvPr id="20" name="Shape 18"/>
+          <p:cNvSpPr/>
+          <p:nvPr/>
+        </p:nvSpPr>
+        <p:spPr>
+          <a:xfrm>
+            <a:off x="2724912" y="2048256"/>
+            <a:ext cx="1719072" cy="256032"/>
+          </a:xfrm>
+          <a:prstGeom prst="rect">
+            <a:avLst/>
+          </a:prstGeom>
+          <a:solidFill>
+            <a:srgbClr val="007B8A"/>
+          </a:solidFill>
+          <a:ln w="12700">
+            <a:solidFill>
+              <a:srgbClr val="007B8A"/>
+            </a:solidFill>
+            <a:prstDash val="solid"/>
+          </a:ln>
+        </p:spPr>
+      </p:sp>
+      <p:sp>
+        <p:nvSpPr>
+          <p:cNvPr id="21" name="Text 19"/>
+          <p:cNvSpPr/>
+          <p:nvPr/>
+        </p:nvSpPr>
+        <p:spPr>
+          <a:xfrm>
+            <a:off x="2724912" y="2048256"/>
+            <a:ext cx="1719072" cy="256032"/>
+          </a:xfrm>
+          <a:prstGeom prst="rect">
+            <a:avLst/>
+          </a:prstGeom>
+          <a:noFill/>
+          <a:ln/>
+        </p:spPr>
+        <p:txBody>
+          <a:bodyPr wrap="square" lIns="0" tIns="0" rIns="0" bIns="0" rtlCol="0" anchor="ctr"/>
+          <a:lstStyle/>
+          <a:p>
+            <a:pPr algn="ctr" indent="0" marL="0">
+              <a:buNone/>
+            </a:pPr>
+            <a:r>
+              <a:rPr lang="en-US" sz="800" b="1" dirty="0">
+                <a:solidFill>
+                  <a:srgbClr val="FFFFFF"/>
+                </a:solidFill>
+              </a:rPr>
+              <a:t>AHEAD</a:t>
+            </a:r>
+            <a:endParaRPr lang="en-US" sz="800" dirty="0"/>
+          </a:p>
+        </p:txBody>
+      </p:sp>
+      <p:sp>
+        <p:nvSpPr>
+          <p:cNvPr id="22" name="Text 20"/>
+          <p:cNvSpPr/>
+          <p:nvPr/>
+        </p:nvSpPr>
+        <p:spPr>
+          <a:xfrm>
+            <a:off x="2724912" y="2377440"/>
+            <a:ext cx="1719072" cy="320040"/>
+          </a:xfrm>
+          <a:prstGeom prst="rect">
+            <a:avLst/>
+          </a:prstGeom>
+          <a:noFill/>
+          <a:ln/>
+        </p:spPr>
+        <p:txBody>
+          <a:bodyPr wrap="square" lIns="0" tIns="0" rIns="0" bIns="0" rtlCol="0" anchor="ctr"/>
+          <a:lstStyle/>
+          <a:p>
+            <a:pPr indent="0" marL="0">
+              <a:buNone/>
+            </a:pPr>
+            <a:r>
+              <a:rPr lang="en-US" sz="1100" b="1" dirty="0">
+                <a:solidFill>
+                  <a:srgbClr val="1A1A1A"/>
+                </a:solidFill>
+              </a:rPr>
+              <a:t>Baseline + BERT both done</a:t>
+            </a:r>
+            <a:endParaRPr lang="en-US" sz="1100" dirty="0"/>
+          </a:p>
+        </p:txBody>
+      </p:sp>
+      <p:sp>
+        <p:nvSpPr>
+          <p:cNvPr id="23" name="Text 21"/>
+          <p:cNvSpPr/>
+          <p:nvPr/>
+        </p:nvSpPr>
+        <p:spPr>
+          <a:xfrm>
+            <a:off x="2724912" y="2724912"/>
+            <a:ext cx="1719072" cy="2039112"/>
+          </a:xfrm>
+          <a:prstGeom prst="rect">
+            <a:avLst/>
+          </a:prstGeom>
+          <a:noFill/>
+          <a:ln/>
+        </p:spPr>
+        <p:txBody>
+          <a:bodyPr wrap="square" lIns="0" tIns="0" rIns="0" bIns="0" rtlCol="0" anchor="ctr"/>
+          <a:lstStyle/>
+          <a:p>
+            <a:pPr indent="0" marL="0">
+              <a:buNone/>
+            </a:pPr>
+            <a:r>
+              <a:rPr lang="en-US" sz="950" dirty="0">
+                <a:solidFill>
+                  <a:srgbClr val="4A4A4A"/>
+                </a:solidFill>
+              </a:rPr>
+              <a:t>Both pipelines completed</a:t>
+            </a:r>
+            <a:endParaRPr lang="en-US" sz="950" dirty="0"/>
+          </a:p>
+          <a:p>
+            <a:pPr indent="0" marL="0">
+              <a:buNone/>
+            </a:pPr>
+            <a:r>
+              <a:rPr lang="en-US" sz="950" dirty="0">
+                <a:solidFill>
+                  <a:srgbClr val="4A4A4A"/>
+                </a:solidFill>
+              </a:rPr>
+              <a:t>in the same week</a:t>
+            </a:r>
+            <a:endParaRPr lang="en-US" sz="950" dirty="0"/>
+          </a:p>
+          <a:p>
+            <a:pPr indent="0" marL="0">
+              <a:buNone/>
+            </a:pPr>
+            <a:r>
+              <a:rPr lang="en-US" sz="950" dirty="0">
+                <a:solidFill>
+                  <a:srgbClr val="4A4A4A"/>
+                </a:solidFill>
+              </a:rPr>
+              <a:t>(proposed as separate weeks)</a:t>
+            </a:r>
+            <a:endParaRPr lang="en-US" sz="950" dirty="0"/>
+          </a:p>
+        </p:txBody>
+      </p:sp>
+      <p:sp>
+        <p:nvSpPr>
+          <p:cNvPr id="24" name="Shape 22"/>
+          <p:cNvSpPr/>
+          <p:nvPr/>
+        </p:nvSpPr>
+        <p:spPr>
+          <a:xfrm>
+            <a:off x="4608576" y="1097280"/>
+            <a:ext cx="1901952" cy="868680"/>
+          </a:xfrm>
+          <a:prstGeom prst="rect">
+            <a:avLst/>
+          </a:prstGeom>
+          <a:solidFill>
+            <a:srgbClr val="FAF7F2"/>
+          </a:solidFill>
+          <a:ln w="12700">
+            <a:solidFill>
+              <a:srgbClr val="D8D0C0"/>
+            </a:solidFill>
+            <a:prstDash val="solid"/>
+          </a:ln>
+        </p:spPr>
+      </p:sp>
+      <p:sp>
+        <p:nvSpPr>
+          <p:cNvPr id="25" name="Text 23"/>
+          <p:cNvSpPr/>
+          <p:nvPr/>
+        </p:nvSpPr>
+        <p:spPr>
+          <a:xfrm>
+            <a:off x="4700016" y="1124712"/>
+            <a:ext cx="1719072" cy="228600"/>
+          </a:xfrm>
+          <a:prstGeom prst="rect">
+            <a:avLst/>
+          </a:prstGeom>
+          <a:noFill/>
+          <a:ln/>
+        </p:spPr>
+        <p:txBody>
+          <a:bodyPr wrap="square" lIns="0" tIns="0" rIns="0" bIns="0" rtlCol="0" anchor="ctr"/>
+          <a:lstStyle/>
+          <a:p>
+            <a:pPr indent="0" marL="0">
+              <a:buNone/>
+            </a:pPr>
+            <a:r>
+              <a:rPr lang="en-US" sz="1100" b="1" dirty="0">
+                <a:solidFill>
+                  <a:srgbClr val="1A1A1A"/>
+                </a:solidFill>
+              </a:rPr>
+              <a:t>Week 3</a:t>
+            </a:r>
+            <a:endParaRPr lang="en-US" sz="1100" dirty="0"/>
+          </a:p>
+        </p:txBody>
+      </p:sp>
+      <p:sp>
+        <p:nvSpPr>
+          <p:cNvPr id="26" name="Text 24"/>
+          <p:cNvSpPr/>
+          <p:nvPr/>
+        </p:nvSpPr>
+        <p:spPr>
+          <a:xfrm>
+            <a:off x="4700016" y="1344168"/>
+            <a:ext cx="1719072" cy="566928"/>
+          </a:xfrm>
+          <a:prstGeom prst="rect">
+            <a:avLst/>
+          </a:prstGeom>
+          <a:noFill/>
+          <a:ln/>
+        </p:spPr>
+        <p:txBody>
+          <a:bodyPr wrap="square" lIns="0" tIns="0" rIns="0" bIns="0" rtlCol="0" anchor="ctr"/>
+          <a:lstStyle/>
+          <a:p>
+            <a:pPr indent="0" marL="0">
+              <a:buNone/>
+            </a:pPr>
+            <a:r>
+              <a:rPr lang="en-US" sz="950" dirty="0">
+                <a:solidFill>
+                  <a:srgbClr val="4A4A4A"/>
+                </a:solidFill>
+              </a:rPr>
+              <a:t>Fine-tune BERT;</a:t>
+            </a:r>
+            <a:endParaRPr lang="en-US" sz="950" dirty="0"/>
+          </a:p>
+          <a:p>
+            <a:pPr indent="0" marL="0">
+              <a:buNone/>
+            </a:pPr>
+            <a:r>
+              <a:rPr lang="en-US" sz="950" dirty="0">
+                <a:solidFill>
+                  <a:srgbClr val="4A4A4A"/>
+                </a:solidFill>
+              </a:rPr>
+              <a:t>compare vs baseline</a:t>
+            </a:r>
+            <a:endParaRPr lang="en-US" sz="950" dirty="0"/>
+          </a:p>
+        </p:txBody>
+      </p:sp>
+      <p:sp>
+        <p:nvSpPr>
+          <p:cNvPr id="27" name="Shape 25"/>
+          <p:cNvSpPr/>
+          <p:nvPr/>
+        </p:nvSpPr>
+        <p:spPr>
+          <a:xfrm>
+            <a:off x="5358384" y="1463040"/>
+            <a:ext cx="402336" cy="402336"/>
+          </a:xfrm>
+          <a:prstGeom prst="ellipse">
+            <a:avLst/>
+          </a:prstGeom>
+          <a:solidFill>
+            <a:srgbClr val="FFFFFF"/>
+          </a:solidFill>
+          <a:ln w="25400">
+            <a:solidFill>
+              <a:srgbClr val="1A1A1A"/>
+            </a:solidFill>
+            <a:prstDash val="solid"/>
+          </a:ln>
+        </p:spPr>
+      </p:sp>
+      <p:sp>
+        <p:nvSpPr>
+          <p:cNvPr id="28" name="Text 26"/>
+          <p:cNvSpPr/>
+          <p:nvPr/>
+        </p:nvSpPr>
+        <p:spPr>
+          <a:xfrm>
+            <a:off x="5358384" y="1463040"/>
+            <a:ext cx="402336" cy="402336"/>
+          </a:xfrm>
+          <a:prstGeom prst="rect">
+            <a:avLst/>
+          </a:prstGeom>
+          <a:noFill/>
+          <a:ln/>
+        </p:spPr>
+        <p:txBody>
+          <a:bodyPr wrap="square" lIns="0" tIns="0" rIns="0" bIns="0" rtlCol="0" anchor="ctr"/>
+          <a:lstStyle/>
+          <a:p>
+            <a:pPr algn="ctr" indent="0" marL="0">
+              <a:buNone/>
+            </a:pPr>
+            <a:r>
+              <a:rPr lang="en-US" sz="1000" b="1" dirty="0">
+                <a:solidFill>
+                  <a:srgbClr val="1A1A1A"/>
+                </a:solidFill>
+              </a:rPr>
+              <a:t>3</a:t>
+            </a:r>
+            <a:endParaRPr lang="en-US" sz="1000" dirty="0"/>
+          </a:p>
+        </p:txBody>
+      </p:sp>
+      <p:sp>
+        <p:nvSpPr>
+          <p:cNvPr id="29" name="Shape 27"/>
+          <p:cNvSpPr/>
+          <p:nvPr/>
+        </p:nvSpPr>
+        <p:spPr>
+          <a:xfrm>
+            <a:off x="4608576" y="1975104"/>
+            <a:ext cx="1901952" cy="2825496"/>
+          </a:xfrm>
+          <a:prstGeom prst="rect">
+            <a:avLst/>
+          </a:prstGeom>
+          <a:solidFill>
+            <a:srgbClr val="FAF7F2"/>
+          </a:solidFill>
+          <a:ln w="12700">
+            <a:solidFill>
+              <a:srgbClr val="D8D0C0"/>
+            </a:solidFill>
+            <a:prstDash val="solid"/>
+          </a:ln>
+        </p:spPr>
+      </p:sp>
+      <p:sp>
+        <p:nvSpPr>
+          <p:cNvPr id="30" name="Text 28"/>
+          <p:cNvSpPr/>
+          <p:nvPr/>
+        </p:nvSpPr>
+        <p:spPr>
+          <a:xfrm>
+            <a:off x="4700016" y="2066544"/>
+            <a:ext cx="1719072" cy="320040"/>
+          </a:xfrm>
+          <a:prstGeom prst="rect">
+            <a:avLst/>
+          </a:prstGeom>
+          <a:noFill/>
+          <a:ln/>
+        </p:spPr>
+        <p:txBody>
+          <a:bodyPr wrap="square" lIns="0" tIns="0" rIns="0" bIns="0" rtlCol="0" anchor="ctr"/>
+          <a:lstStyle/>
+          <a:p>
+            <a:pPr indent="0" marL="0">
+              <a:buNone/>
+            </a:pPr>
+            <a:r>
+              <a:rPr lang="en-US" sz="1100" b="1" dirty="0">
+                <a:solidFill>
+                  <a:srgbClr val="1A1A1A"/>
+                </a:solidFill>
+              </a:rPr>
+              <a:t>Evaluation added</a:t>
+            </a:r>
+            <a:endParaRPr lang="en-US" sz="1100" dirty="0"/>
+          </a:p>
+        </p:txBody>
+      </p:sp>
+      <p:sp>
+        <p:nvSpPr>
+          <p:cNvPr id="31" name="Text 29"/>
+          <p:cNvSpPr/>
+          <p:nvPr/>
+        </p:nvSpPr>
+        <p:spPr>
+          <a:xfrm>
+            <a:off x="4700016" y="2414016"/>
+            <a:ext cx="1719072" cy="2350008"/>
+          </a:xfrm>
+          <a:prstGeom prst="rect">
+            <a:avLst/>
+          </a:prstGeom>
+          <a:noFill/>
+          <a:ln/>
+        </p:spPr>
+        <p:txBody>
+          <a:bodyPr wrap="square" lIns="0" tIns="0" rIns="0" bIns="0" rtlCol="0" anchor="ctr"/>
+          <a:lstStyle/>
+          <a:p>
+            <a:pPr indent="0" marL="0">
+              <a:buNone/>
+            </a:pPr>
+            <a:r>
+              <a:rPr lang="en-US" sz="950" dirty="0">
+                <a:solidFill>
+                  <a:srgbClr val="4A4A4A"/>
+                </a:solidFill>
+              </a:rPr>
+              <a:t>Error analysis complete</a:t>
+            </a:r>
+            <a:endParaRPr lang="en-US" sz="950" dirty="0"/>
+          </a:p>
+          <a:p>
+            <a:pPr indent="0" marL="0">
+              <a:buNone/>
+            </a:pPr>
+            <a:r>
+              <a:rPr lang="en-US" sz="950" dirty="0">
+                <a:solidFill>
+                  <a:srgbClr val="4A4A4A"/>
+                </a:solidFill>
+              </a:rPr>
+              <a:t>BBC test accuracy ~97.8%</a:t>
+            </a:r>
+            <a:endParaRPr lang="en-US" sz="950" dirty="0"/>
+          </a:p>
+          <a:p>
+            <a:pPr indent="0" marL="0">
+              <a:buNone/>
+            </a:pPr>
+            <a:r>
+              <a:rPr lang="en-US" sz="950" dirty="0">
+                <a:solidFill>
+                  <a:srgbClr val="4A4A4A"/>
+                </a:solidFill>
+              </a:rPr>
+              <a:t>Dataset felt too small</a:t>
+            </a:r>
+            <a:endParaRPr lang="en-US" sz="950" dirty="0"/>
+          </a:p>
+        </p:txBody>
+      </p:sp>
+      <p:sp>
+        <p:nvSpPr>
+          <p:cNvPr id="32" name="Shape 30"/>
+          <p:cNvSpPr/>
+          <p:nvPr/>
+        </p:nvSpPr>
+        <p:spPr>
+          <a:xfrm>
+            <a:off x="6583680" y="1097280"/>
+            <a:ext cx="1901952" cy="868680"/>
           </a:xfrm>
           <a:prstGeom prst="rect">
             <a:avLst/>
@@ -2818,14 +3631,125 @@
       </p:sp>
       <p:sp>
         <p:nvSpPr>
-          <p:cNvPr id="4" name="Text 2"/>
-          <p:cNvSpPr/>
-          <p:nvPr/>
-        </p:nvSpPr>
-        <p:spPr>
-          <a:xfrm>
-            <a:off x="457200" y="868680"/>
-            <a:ext cx="1508760" cy="347472"/>
+          <p:cNvPr id="33" name="Text 31"/>
+          <p:cNvSpPr/>
+          <p:nvPr/>
+        </p:nvSpPr>
+        <p:spPr>
+          <a:xfrm>
+            <a:off x="6675120" y="1124712"/>
+            <a:ext cx="1719072" cy="228600"/>
+          </a:xfrm>
+          <a:prstGeom prst="rect">
+            <a:avLst/>
+          </a:prstGeom>
+          <a:noFill/>
+          <a:ln/>
+        </p:spPr>
+        <p:txBody>
+          <a:bodyPr wrap="square" lIns="0" tIns="0" rIns="0" bIns="0" rtlCol="0" anchor="ctr"/>
+          <a:lstStyle/>
+          <a:p>
+            <a:pPr indent="0" marL="0">
+              <a:buNone/>
+            </a:pPr>
+            <a:r>
+              <a:rPr lang="en-US" sz="1100" b="1" dirty="0">
+                <a:solidFill>
+                  <a:srgbClr val="FFFFFF"/>
+                </a:solidFill>
+              </a:rPr>
+              <a:t>Week 4</a:t>
+            </a:r>
+            <a:endParaRPr lang="en-US" sz="1100" dirty="0"/>
+          </a:p>
+        </p:txBody>
+      </p:sp>
+      <p:sp>
+        <p:nvSpPr>
+          <p:cNvPr id="34" name="Text 32"/>
+          <p:cNvSpPr/>
+          <p:nvPr/>
+        </p:nvSpPr>
+        <p:spPr>
+          <a:xfrm>
+            <a:off x="6675120" y="1344168"/>
+            <a:ext cx="1719072" cy="566928"/>
+          </a:xfrm>
+          <a:prstGeom prst="rect">
+            <a:avLst/>
+          </a:prstGeom>
+          <a:noFill/>
+          <a:ln/>
+        </p:spPr>
+        <p:txBody>
+          <a:bodyPr wrap="square" lIns="0" tIns="0" rIns="0" bIns="0" rtlCol="0" anchor="ctr"/>
+          <a:lstStyle/>
+          <a:p>
+            <a:pPr indent="0" marL="0">
+              <a:buNone/>
+            </a:pPr>
+            <a:r>
+              <a:rPr lang="en-US" sz="950" dirty="0">
+                <a:solidFill>
+                  <a:srgbClr val="CCCCCC"/>
+                </a:solidFill>
+              </a:rPr>
+              <a:t>Error analysis &amp;</a:t>
+            </a:r>
+            <a:endParaRPr lang="en-US" sz="950" dirty="0"/>
+          </a:p>
+          <a:p>
+            <a:pPr indent="0" marL="0">
+              <a:buNone/>
+            </a:pPr>
+            <a:r>
+              <a:rPr lang="en-US" sz="950" dirty="0">
+                <a:solidFill>
+                  <a:srgbClr val="CCCCCC"/>
+                </a:solidFill>
+              </a:rPr>
+              <a:t>presentation</a:t>
+            </a:r>
+            <a:endParaRPr lang="en-US" sz="950" dirty="0"/>
+          </a:p>
+        </p:txBody>
+      </p:sp>
+      <p:sp>
+        <p:nvSpPr>
+          <p:cNvPr id="35" name="Shape 33"/>
+          <p:cNvSpPr/>
+          <p:nvPr/>
+        </p:nvSpPr>
+        <p:spPr>
+          <a:xfrm>
+            <a:off x="7333488" y="1463040"/>
+            <a:ext cx="402336" cy="402336"/>
+          </a:xfrm>
+          <a:prstGeom prst="ellipse">
+            <a:avLst/>
+          </a:prstGeom>
+          <a:solidFill>
+            <a:srgbClr val="1A1A1A"/>
+          </a:solidFill>
+          <a:ln w="25400">
+            <a:solidFill>
+              <a:srgbClr val="1A1A1A"/>
+            </a:solidFill>
+            <a:prstDash val="solid"/>
+          </a:ln>
+        </p:spPr>
+      </p:sp>
+      <p:sp>
+        <p:nvSpPr>
+          <p:cNvPr id="36" name="Text 34"/>
+          <p:cNvSpPr/>
+          <p:nvPr/>
+        </p:nvSpPr>
+        <p:spPr>
+          <a:xfrm>
+            <a:off x="7333488" y="1463040"/>
+            <a:ext cx="402336" cy="402336"/>
           </a:xfrm>
           <a:prstGeom prst="rect">
             <a:avLst/>
@@ -2841,27 +3765,27 @@
               <a:buNone/>
             </a:pPr>
             <a:r>
-              <a:rPr lang="en-US" sz="1300" dirty="0">
+              <a:rPr lang="en-US" sz="1000" b="1" dirty="0">
                 <a:solidFill>
                   <a:srgbClr val="FFFFFF"/>
                 </a:solidFill>
               </a:rPr>
-              <a:t>Planned</a:t>
-            </a:r>
-            <a:endParaRPr lang="en-US" sz="1300" dirty="0"/>
-          </a:p>
-        </p:txBody>
-      </p:sp>
-      <p:sp>
-        <p:nvSpPr>
-          <p:cNvPr id="5" name="Shape 3"/>
-          <p:cNvSpPr/>
-          <p:nvPr/>
-        </p:nvSpPr>
-        <p:spPr>
-          <a:xfrm>
-            <a:off x="2057400" y="868680"/>
-            <a:ext cx="3337560" cy="347472"/>
+              <a:t>4</a:t>
+            </a:r>
+            <a:endParaRPr lang="en-US" sz="1000" dirty="0"/>
+          </a:p>
+        </p:txBody>
+      </p:sp>
+      <p:sp>
+        <p:nvSpPr>
+          <p:cNvPr id="37" name="Shape 35"/>
+          <p:cNvSpPr/>
+          <p:nvPr/>
+        </p:nvSpPr>
+        <p:spPr>
+          <a:xfrm>
+            <a:off x="6583680" y="1975104"/>
+            <a:ext cx="1901952" cy="2825496"/>
           </a:xfrm>
           <a:prstGeom prst="rect">
             <a:avLst/>
@@ -2875,64 +3799,35 @@
             </a:solidFill>
             <a:prstDash val="solid"/>
           </a:ln>
-        </p:spPr>
-      </p:sp>
-      <p:sp>
-        <p:nvSpPr>
-          <p:cNvPr id="6" name="Text 4"/>
-          <p:cNvSpPr/>
-          <p:nvPr/>
-        </p:nvSpPr>
-        <p:spPr>
-          <a:xfrm>
-            <a:off x="2057400" y="868680"/>
-            <a:ext cx="3337560" cy="347472"/>
-          </a:xfrm>
-          <a:prstGeom prst="rect">
-            <a:avLst/>
-          </a:prstGeom>
-          <a:noFill/>
-          <a:ln/>
-        </p:spPr>
-        <p:txBody>
-          <a:bodyPr wrap="square" lIns="0" tIns="0" rIns="0" bIns="0" rtlCol="0" anchor="ctr"/>
-          <a:lstStyle/>
-          <a:p>
-            <a:pPr algn="ctr" indent="0" marL="0">
-              <a:buNone/>
-            </a:pPr>
-            <a:r>
-              <a:rPr lang="en-US" sz="1300" dirty="0">
-                <a:solidFill>
-                  <a:srgbClr val="FFFFFF"/>
-                </a:solidFill>
-              </a:rPr>
-              <a:t>Actual</a:t>
-            </a:r>
-            <a:endParaRPr lang="en-US" sz="1300" dirty="0"/>
-          </a:p>
-        </p:txBody>
-      </p:sp>
-      <p:sp>
-        <p:nvSpPr>
-          <p:cNvPr id="7" name="Shape 5"/>
-          <p:cNvSpPr/>
-          <p:nvPr/>
-        </p:nvSpPr>
-        <p:spPr>
-          <a:xfrm>
-            <a:off x="5486400" y="868680"/>
-            <a:ext cx="3520440" cy="347472"/>
+          <a:effectLst>
+            <a:outerShdw sx="100000" sy="100000" kx="0" ky="0" algn="bl" rotWithShape="0" blurRad="76200" dist="25400" dir="8100000">
+              <a:srgbClr val="000000">
+                <a:alpha val="8000"/>
+              </a:srgbClr>
+            </a:outerShdw>
+          </a:effectLst>
+        </p:spPr>
+      </p:sp>
+      <p:sp>
+        <p:nvSpPr>
+          <p:cNvPr id="38" name="Shape 36"/>
+          <p:cNvSpPr/>
+          <p:nvPr/>
+        </p:nvSpPr>
+        <p:spPr>
+          <a:xfrm>
+            <a:off x="6675120" y="2048256"/>
+            <a:ext cx="1719072" cy="256032"/>
           </a:xfrm>
           <a:prstGeom prst="rect">
             <a:avLst/>
           </a:prstGeom>
           <a:solidFill>
-            <a:srgbClr val="1A1A1A"/>
+            <a:srgbClr val="333333"/>
           </a:solidFill>
           <a:ln w="12700">
             <a:solidFill>
-              <a:srgbClr val="1A1A1A"/>
+              <a:srgbClr val="333333"/>
             </a:solidFill>
             <a:prstDash val="solid"/>
           </a:ln>
@@ -2940,14 +3835,14 @@
       </p:sp>
       <p:sp>
         <p:nvSpPr>
-          <p:cNvPr id="8" name="Text 6"/>
-          <p:cNvSpPr/>
-          <p:nvPr/>
-        </p:nvSpPr>
-        <p:spPr>
-          <a:xfrm>
-            <a:off x="5486400" y="868680"/>
-            <a:ext cx="3520440" cy="347472"/>
+          <p:cNvPr id="39" name="Text 37"/>
+          <p:cNvSpPr/>
+          <p:nvPr/>
+        </p:nvSpPr>
+        <p:spPr>
+          <a:xfrm>
+            <a:off x="6675120" y="2048256"/>
+            <a:ext cx="1719072" cy="256032"/>
           </a:xfrm>
           <a:prstGeom prst="rect">
             <a:avLst/>
@@ -2963,241 +3858,73 @@
               <a:buNone/>
             </a:pPr>
             <a:r>
-              <a:rPr lang="en-US" sz="1300" dirty="0">
+              <a:rPr lang="en-US" sz="800" b="1" dirty="0">
                 <a:solidFill>
                   <a:srgbClr val="FFFFFF"/>
                 </a:solidFill>
               </a:rPr>
-              <a:t>Key Events</a:t>
-            </a:r>
-            <a:endParaRPr lang="en-US" sz="1300" dirty="0"/>
-          </a:p>
-        </p:txBody>
-      </p:sp>
-      <p:sp>
-        <p:nvSpPr>
-          <p:cNvPr id="9" name="Shape 7"/>
-          <p:cNvSpPr/>
-          <p:nvPr/>
-        </p:nvSpPr>
-        <p:spPr>
-          <a:xfrm>
-            <a:off x="457200" y="1325880"/>
-            <a:ext cx="8229600" cy="868680"/>
-          </a:xfrm>
-          <a:prstGeom prst="rect">
-            <a:avLst/>
-          </a:prstGeom>
-          <a:solidFill>
-            <a:srgbClr val="FAF7F2"/>
-          </a:solidFill>
-          <a:ln w="12700">
-            <a:solidFill>
-              <a:srgbClr val="D8D0C0"/>
-            </a:solidFill>
-            <a:prstDash val="solid"/>
-          </a:ln>
-        </p:spPr>
-      </p:sp>
-      <p:sp>
-        <p:nvSpPr>
-          <p:cNvPr id="10" name="Text 8"/>
-          <p:cNvSpPr/>
-          <p:nvPr/>
-        </p:nvSpPr>
-        <p:spPr>
-          <a:xfrm>
-            <a:off x="530352" y="1435608"/>
-            <a:ext cx="1417320" cy="658368"/>
-          </a:xfrm>
-          <a:prstGeom prst="rect">
-            <a:avLst/>
-          </a:prstGeom>
-          <a:noFill/>
-          <a:ln/>
-        </p:spPr>
-        <p:txBody>
-          <a:bodyPr wrap="square" lIns="0" tIns="0" rIns="0" bIns="0" rtlCol="0" anchor="ctr"/>
-          <a:lstStyle/>
-          <a:p>
-            <a:pPr algn="ctr" indent="0" marL="0">
+              <a:t>EXPANDED</a:t>
+            </a:r>
+            <a:endParaRPr lang="en-US" sz="800" dirty="0"/>
+          </a:p>
+        </p:txBody>
+      </p:sp>
+      <p:sp>
+        <p:nvSpPr>
+          <p:cNvPr id="40" name="Text 38"/>
+          <p:cNvSpPr/>
+          <p:nvPr/>
+        </p:nvSpPr>
+        <p:spPr>
+          <a:xfrm>
+            <a:off x="6675120" y="2377440"/>
+            <a:ext cx="1719072" cy="320040"/>
+          </a:xfrm>
+          <a:prstGeom prst="rect">
+            <a:avLst/>
+          </a:prstGeom>
+          <a:noFill/>
+          <a:ln/>
+        </p:spPr>
+        <p:txBody>
+          <a:bodyPr wrap="square" lIns="0" tIns="0" rIns="0" bIns="0" rtlCol="0" anchor="ctr"/>
+          <a:lstStyle/>
+          <a:p>
+            <a:pPr indent="0" marL="0">
               <a:buNone/>
             </a:pPr>
             <a:r>
               <a:rPr lang="en-US" sz="1100" b="1" dirty="0">
                 <a:solidFill>
-                  <a:srgbClr val="1A1A1A"/>
-                </a:solidFill>
-              </a:rPr>
-              <a:t>Week 1</a:t>
+                  <a:srgbClr val="FFFFFF"/>
+                </a:solidFill>
+              </a:rPr>
+              <a:t>Expanded to AG News</a:t>
             </a:r>
             <a:endParaRPr lang="en-US" sz="1100" dirty="0"/>
           </a:p>
-          <a:p>
-            <a:pPr algn="ctr" indent="0" marL="0">
-              <a:buNone/>
-            </a:pPr>
-            <a:r>
-              <a:rPr lang="en-US" sz="1100" b="1" dirty="0">
-                <a:solidFill>
-                  <a:srgbClr val="1A1A1A"/>
-                </a:solidFill>
-              </a:rPr>
-              <a:t>Mar 28</a:t>
-            </a:r>
-            <a:endParaRPr lang="en-US" sz="1100" dirty="0"/>
-          </a:p>
-        </p:txBody>
-      </p:sp>
-      <p:sp>
-        <p:nvSpPr>
-          <p:cNvPr id="11" name="Text 9"/>
-          <p:cNvSpPr/>
-          <p:nvPr/>
-        </p:nvSpPr>
-        <p:spPr>
-          <a:xfrm>
-            <a:off x="2121408" y="1463040"/>
-            <a:ext cx="3200400" cy="658368"/>
-          </a:xfrm>
-          <a:prstGeom prst="rect">
-            <a:avLst/>
-          </a:prstGeom>
-          <a:noFill/>
-          <a:ln/>
-        </p:spPr>
-        <p:txBody>
-          <a:bodyPr wrap="square" lIns="0" tIns="0" rIns="0" bIns="0" rtlCol="0" anchor="ctr"/>
-          <a:lstStyle/>
-          <a:p>
-            <a:pPr indent="0" marL="0">
-              <a:buNone/>
-            </a:pPr>
-            <a:r>
-              <a:rPr lang="en-US" sz="1100" dirty="0">
-                <a:solidFill>
-                  <a:srgbClr val="4A4A4A"/>
-                </a:solidFill>
-              </a:rPr>
-              <a:t>Finalize dataset</a:t>
-            </a:r>
-            <a:endParaRPr lang="en-US" sz="1100" dirty="0"/>
-          </a:p>
-          <a:p>
-            <a:pPr indent="0" marL="0">
-              <a:buNone/>
-            </a:pPr>
-            <a:r>
-              <a:rPr lang="en-US" sz="1100" dirty="0">
-                <a:solidFill>
-                  <a:srgbClr val="4A4A4A"/>
-                </a:solidFill>
-              </a:rPr>
-              <a:t>&amp; preprocessing</a:t>
-            </a:r>
-            <a:endParaRPr lang="en-US" sz="1100" dirty="0"/>
-          </a:p>
-        </p:txBody>
-      </p:sp>
-      <p:sp>
-        <p:nvSpPr>
-          <p:cNvPr id="12" name="Shape 10"/>
-          <p:cNvSpPr/>
-          <p:nvPr/>
-        </p:nvSpPr>
-        <p:spPr>
-          <a:xfrm>
-            <a:off x="5047488" y="1618488"/>
-            <a:ext cx="347472" cy="292608"/>
-          </a:xfrm>
-          <a:prstGeom prst="rect">
-            <a:avLst/>
-          </a:prstGeom>
-          <a:solidFill>
-            <a:srgbClr val="555555"/>
-          </a:solidFill>
-          <a:ln w="12700">
-            <a:solidFill>
-              <a:srgbClr val="555555"/>
-            </a:solidFill>
-            <a:prstDash val="solid"/>
-          </a:ln>
-        </p:spPr>
-      </p:sp>
-      <p:sp>
-        <p:nvSpPr>
-          <p:cNvPr id="13" name="Text 11"/>
-          <p:cNvSpPr/>
-          <p:nvPr/>
-        </p:nvSpPr>
-        <p:spPr>
-          <a:xfrm>
-            <a:off x="5047488" y="1618488"/>
-            <a:ext cx="347472" cy="292608"/>
-          </a:xfrm>
-          <a:prstGeom prst="rect">
-            <a:avLst/>
-          </a:prstGeom>
-          <a:noFill/>
-          <a:ln/>
-        </p:spPr>
-        <p:txBody>
-          <a:bodyPr wrap="square" lIns="0" tIns="0" rIns="0" bIns="0" rtlCol="0" anchor="ctr"/>
-          <a:lstStyle/>
-          <a:p>
-            <a:pPr algn="ctr" indent="0" marL="0">
-              <a:buNone/>
-            </a:pPr>
-            <a:r>
-              <a:rPr lang="en-US" sz="600" b="1" dirty="0">
-                <a:solidFill>
-                  <a:srgbClr val="FFFFFF"/>
-                </a:solidFill>
-              </a:rPr>
-              <a:t>ON TRACK</a:t>
-            </a:r>
-            <a:endParaRPr lang="en-US" sz="600" dirty="0"/>
-          </a:p>
-        </p:txBody>
-      </p:sp>
-      <p:sp>
-        <p:nvSpPr>
-          <p:cNvPr id="14" name="Text 12"/>
-          <p:cNvSpPr/>
-          <p:nvPr/>
-        </p:nvSpPr>
-        <p:spPr>
-          <a:xfrm>
-            <a:off x="5532120" y="1399032"/>
-            <a:ext cx="3017520" cy="722376"/>
-          </a:xfrm>
-          <a:prstGeom prst="rect">
-            <a:avLst/>
-          </a:prstGeom>
-          <a:noFill/>
-          <a:ln/>
-        </p:spPr>
-        <p:txBody>
-          <a:bodyPr wrap="square" rtlCol="0" anchor="ctr"/>
-          <a:lstStyle/>
-          <a:p>
-            <a:pPr marL="342900" indent="-342900">
-              <a:spcAft>
-                <a:spcPts val="100"/>
-              </a:spcAft>
-              <a:buSzPct val="100000"/>
-              <a:buChar char="•"/>
-            </a:pPr>
-            <a:r>
-              <a:rPr lang="en-US" sz="1050" b="1" dirty="0">
-                <a:solidFill>
-                  <a:srgbClr val="1A1A1A"/>
-                </a:solidFill>
-              </a:rPr>
-              <a:t>Mar 28 — BBC News pipeline complete</a:t>
-            </a:r>
-            <a:endParaRPr lang="en-US" sz="1050" dirty="0"/>
-          </a:p>
+        </p:txBody>
+      </p:sp>
+      <p:sp>
+        <p:nvSpPr>
+          <p:cNvPr id="41" name="Text 39"/>
+          <p:cNvSpPr/>
+          <p:nvPr/>
+        </p:nvSpPr>
+        <p:spPr>
+          <a:xfrm>
+            <a:off x="6675120" y="2724912"/>
+            <a:ext cx="1719072" cy="2039112"/>
+          </a:xfrm>
+          <a:prstGeom prst="rect">
+            <a:avLst/>
+          </a:prstGeom>
+          <a:noFill/>
+          <a:ln/>
+        </p:spPr>
+        <p:txBody>
+          <a:bodyPr wrap="square" lIns="0" tIns="0" rIns="0" bIns="0" rtlCol="0" anchor="ctr"/>
+          <a:lstStyle/>
           <a:p>
             <a:pPr indent="0" marL="0">
               <a:buNone/>
@@ -3205,908 +3932,74 @@
             <a:r>
               <a:rPr lang="en-US" sz="950" dirty="0">
                 <a:solidFill>
+                  <a:srgbClr val="CCCCCC"/>
+                </a:solidFill>
+              </a:rPr>
+              <a:t>Migrated pipeline to AG News</a:t>
+            </a:r>
+            <a:endParaRPr lang="en-US" sz="950" dirty="0"/>
+          </a:p>
+          <a:p>
+            <a:pPr indent="0" marL="0">
+              <a:buNone/>
+            </a:pPr>
+            <a:r>
+              <a:rPr lang="en-US" sz="950" dirty="0">
+                <a:solidFill>
+                  <a:srgbClr val="CCCCCC"/>
+                </a:solidFill>
+              </a:rPr>
+              <a:t>All three models updated</a:t>
+            </a:r>
+            <a:endParaRPr lang="en-US" sz="950" dirty="0"/>
+          </a:p>
+          <a:p>
+            <a:pPr indent="0" marL="0">
+              <a:buNone/>
+            </a:pPr>
+            <a:r>
+              <a:rPr lang="en-US" sz="950" dirty="0">
+                <a:solidFill>
+                  <a:srgbClr val="CCCCCC"/>
+                </a:solidFill>
+              </a:rPr>
+              <a:t>within 2 days</a:t>
+            </a:r>
+            <a:endParaRPr lang="en-US" sz="950" dirty="0"/>
+          </a:p>
+        </p:txBody>
+      </p:sp>
+      <p:sp>
+        <p:nvSpPr>
+          <p:cNvPr id="42" name="Text 40"/>
+          <p:cNvSpPr/>
+          <p:nvPr/>
+        </p:nvSpPr>
+        <p:spPr>
+          <a:xfrm>
+            <a:off x="457200" y="4828032"/>
+            <a:ext cx="8229600" cy="274320"/>
+          </a:xfrm>
+          <a:prstGeom prst="rect">
+            <a:avLst/>
+          </a:prstGeom>
+          <a:noFill/>
+          <a:ln/>
+        </p:spPr>
+        <p:txBody>
+          <a:bodyPr wrap="square" lIns="0" tIns="0" rIns="0" bIns="0" rtlCol="0" anchor="ctr"/>
+          <a:lstStyle/>
+          <a:p>
+            <a:pPr algn="l" indent="0" marL="0">
+              <a:buNone/>
+            </a:pPr>
+            <a:r>
+              <a:rPr lang="en-US" sz="900" i="1" dirty="0">
+                <a:solidFill>
                   <a:srgbClr val="888888"/>
                 </a:solidFill>
               </a:rPr>
-              <a:t>download_data.py + data_preprocessing.py</a:t>
-            </a:r>
-            <a:endParaRPr lang="en-US" sz="1050" dirty="0"/>
-          </a:p>
-          <a:p>
-            <a:pPr indent="0" marL="0">
-              <a:buNone/>
-            </a:pPr>
-            <a:r>
-              <a:rPr lang="en-US" sz="950" dirty="0">
-                <a:solidFill>
-                  <a:srgbClr val="888888"/>
-                </a:solidFill>
-              </a:rPr>
-              <a:t>All processed CSVs committed to repo</a:t>
-            </a:r>
-            <a:endParaRPr lang="en-US" sz="1050" dirty="0"/>
-          </a:p>
-        </p:txBody>
-      </p:sp>
-      <p:sp>
-        <p:nvSpPr>
-          <p:cNvPr id="15" name="Shape 13"/>
-          <p:cNvSpPr/>
-          <p:nvPr/>
-        </p:nvSpPr>
-        <p:spPr>
-          <a:xfrm>
-            <a:off x="457200" y="2258568"/>
-            <a:ext cx="8229600" cy="868680"/>
-          </a:xfrm>
-          <a:prstGeom prst="rect">
-            <a:avLst/>
-          </a:prstGeom>
-          <a:solidFill>
-            <a:srgbClr val="F5F0E8"/>
-          </a:solidFill>
-          <a:ln w="12700">
-            <a:solidFill>
-              <a:srgbClr val="D8D0C0"/>
-            </a:solidFill>
-            <a:prstDash val="solid"/>
-          </a:ln>
-        </p:spPr>
-      </p:sp>
-      <p:sp>
-        <p:nvSpPr>
-          <p:cNvPr id="16" name="Text 14"/>
-          <p:cNvSpPr/>
-          <p:nvPr/>
-        </p:nvSpPr>
-        <p:spPr>
-          <a:xfrm>
-            <a:off x="530352" y="2368296"/>
-            <a:ext cx="1417320" cy="658368"/>
-          </a:xfrm>
-          <a:prstGeom prst="rect">
-            <a:avLst/>
-          </a:prstGeom>
-          <a:noFill/>
-          <a:ln/>
-        </p:spPr>
-        <p:txBody>
-          <a:bodyPr wrap="square" lIns="0" tIns="0" rIns="0" bIns="0" rtlCol="0" anchor="ctr"/>
-          <a:lstStyle/>
-          <a:p>
-            <a:pPr algn="ctr" indent="0" marL="0">
-              <a:buNone/>
-            </a:pPr>
-            <a:r>
-              <a:rPr lang="en-US" sz="1100" b="1" dirty="0">
-                <a:solidFill>
-                  <a:srgbClr val="1A1A1A"/>
-                </a:solidFill>
-              </a:rPr>
-              <a:t>Week 2</a:t>
-            </a:r>
-            <a:endParaRPr lang="en-US" sz="1100" dirty="0"/>
-          </a:p>
-          <a:p>
-            <a:pPr algn="ctr" indent="0" marL="0">
-              <a:buNone/>
-            </a:pPr>
-            <a:r>
-              <a:rPr lang="en-US" sz="1100" b="1" dirty="0">
-                <a:solidFill>
-                  <a:srgbClr val="1A1A1A"/>
-                </a:solidFill>
-              </a:rPr>
-              <a:t>Mar 30</a:t>
-            </a:r>
-            <a:endParaRPr lang="en-US" sz="1100" dirty="0"/>
-          </a:p>
-        </p:txBody>
-      </p:sp>
-      <p:sp>
-        <p:nvSpPr>
-          <p:cNvPr id="17" name="Text 15"/>
-          <p:cNvSpPr/>
-          <p:nvPr/>
-        </p:nvSpPr>
-        <p:spPr>
-          <a:xfrm>
-            <a:off x="2121408" y="2395728"/>
-            <a:ext cx="3200400" cy="658368"/>
-          </a:xfrm>
-          <a:prstGeom prst="rect">
-            <a:avLst/>
-          </a:prstGeom>
-          <a:noFill/>
-          <a:ln/>
-        </p:spPr>
-        <p:txBody>
-          <a:bodyPr wrap="square" lIns="0" tIns="0" rIns="0" bIns="0" rtlCol="0" anchor="ctr"/>
-          <a:lstStyle/>
-          <a:p>
-            <a:pPr indent="0" marL="0">
-              <a:buNone/>
-            </a:pPr>
-            <a:r>
-              <a:rPr lang="en-US" sz="1100" dirty="0">
-                <a:solidFill>
-                  <a:srgbClr val="4A4A4A"/>
-                </a:solidFill>
-              </a:rPr>
-              <a:t>Baseline classifier</a:t>
-            </a:r>
-            <a:endParaRPr lang="en-US" sz="1100" dirty="0"/>
-          </a:p>
-          <a:p>
-            <a:pPr indent="0" marL="0">
-              <a:buNone/>
-            </a:pPr>
-            <a:r>
-              <a:rPr lang="en-US" sz="1100" dirty="0">
-                <a:solidFill>
-                  <a:srgbClr val="4A4A4A"/>
-                </a:solidFill>
-              </a:rPr>
-              <a:t>(n-gram + LR)</a:t>
-            </a:r>
-            <a:endParaRPr lang="en-US" sz="1100" dirty="0"/>
-          </a:p>
-        </p:txBody>
-      </p:sp>
-      <p:sp>
-        <p:nvSpPr>
-          <p:cNvPr id="18" name="Shape 16"/>
-          <p:cNvSpPr/>
-          <p:nvPr/>
-        </p:nvSpPr>
-        <p:spPr>
-          <a:xfrm>
-            <a:off x="5047488" y="2551176"/>
-            <a:ext cx="347472" cy="292608"/>
-          </a:xfrm>
-          <a:prstGeom prst="rect">
-            <a:avLst/>
-          </a:prstGeom>
-          <a:solidFill>
-            <a:srgbClr val="007B8A"/>
-          </a:solidFill>
-          <a:ln w="12700">
-            <a:solidFill>
-              <a:srgbClr val="007B8A"/>
-            </a:solidFill>
-            <a:prstDash val="solid"/>
-          </a:ln>
-        </p:spPr>
-      </p:sp>
-      <p:sp>
-        <p:nvSpPr>
-          <p:cNvPr id="19" name="Text 17"/>
-          <p:cNvSpPr/>
-          <p:nvPr/>
-        </p:nvSpPr>
-        <p:spPr>
-          <a:xfrm>
-            <a:off x="5047488" y="2551176"/>
-            <a:ext cx="347472" cy="292608"/>
-          </a:xfrm>
-          <a:prstGeom prst="rect">
-            <a:avLst/>
-          </a:prstGeom>
-          <a:noFill/>
-          <a:ln/>
-        </p:spPr>
-        <p:txBody>
-          <a:bodyPr wrap="square" lIns="0" tIns="0" rIns="0" bIns="0" rtlCol="0" anchor="ctr"/>
-          <a:lstStyle/>
-          <a:p>
-            <a:pPr algn="ctr" indent="0" marL="0">
-              <a:buNone/>
-            </a:pPr>
-            <a:r>
-              <a:rPr lang="en-US" sz="600" b="1" dirty="0">
-                <a:solidFill>
-                  <a:srgbClr val="FFFFFF"/>
-                </a:solidFill>
-              </a:rPr>
-              <a:t>AHEAD</a:t>
-            </a:r>
-            <a:endParaRPr lang="en-US" sz="600" dirty="0"/>
-          </a:p>
-        </p:txBody>
-      </p:sp>
-      <p:sp>
-        <p:nvSpPr>
-          <p:cNvPr id="20" name="Text 18"/>
-          <p:cNvSpPr/>
-          <p:nvPr/>
-        </p:nvSpPr>
-        <p:spPr>
-          <a:xfrm>
-            <a:off x="5532120" y="2331720"/>
-            <a:ext cx="3017520" cy="722376"/>
-          </a:xfrm>
-          <a:prstGeom prst="rect">
-            <a:avLst/>
-          </a:prstGeom>
-          <a:noFill/>
-          <a:ln/>
-        </p:spPr>
-        <p:txBody>
-          <a:bodyPr wrap="square" rtlCol="0" anchor="ctr"/>
-          <a:lstStyle/>
-          <a:p>
-            <a:pPr marL="342900" indent="-342900">
-              <a:spcAft>
-                <a:spcPts val="100"/>
-              </a:spcAft>
-              <a:buSzPct val="100000"/>
-              <a:buChar char="•"/>
-            </a:pPr>
-            <a:r>
-              <a:rPr lang="en-US" sz="1050" b="1" dirty="0">
-                <a:solidFill>
-                  <a:srgbClr val="1A1A1A"/>
-                </a:solidFill>
-              </a:rPr>
-              <a:t>Mar 30 — Baseline + BERT both added</a:t>
-            </a:r>
-            <a:endParaRPr lang="en-US" sz="1050" dirty="0"/>
-          </a:p>
-          <a:p>
-            <a:pPr indent="0" marL="0">
-              <a:buNone/>
-            </a:pPr>
-            <a:r>
-              <a:rPr lang="en-US" sz="950" dirty="0">
-                <a:solidFill>
-                  <a:srgbClr val="888888"/>
-                </a:solidFill>
-              </a:rPr>
-              <a:t>Both pipelines completed in the same week</a:t>
-            </a:r>
-            <a:endParaRPr lang="en-US" sz="1050" dirty="0"/>
-          </a:p>
-          <a:p>
-            <a:pPr indent="0" marL="0">
-              <a:buNone/>
-            </a:pPr>
-            <a:r>
-              <a:rPr lang="en-US" sz="950" dirty="0">
-                <a:solidFill>
-                  <a:srgbClr val="888888"/>
-                </a:solidFill>
-              </a:rPr>
-              <a:t>(Proposal had them in separate weeks)</a:t>
-            </a:r>
-            <a:endParaRPr lang="en-US" sz="1050" dirty="0"/>
-          </a:p>
-        </p:txBody>
-      </p:sp>
-      <p:sp>
-        <p:nvSpPr>
-          <p:cNvPr id="21" name="Shape 19"/>
-          <p:cNvSpPr/>
-          <p:nvPr/>
-        </p:nvSpPr>
-        <p:spPr>
-          <a:xfrm>
-            <a:off x="457200" y="3191256"/>
-            <a:ext cx="8229600" cy="868680"/>
-          </a:xfrm>
-          <a:prstGeom prst="rect">
-            <a:avLst/>
-          </a:prstGeom>
-          <a:solidFill>
-            <a:srgbClr val="FAF7F2"/>
-          </a:solidFill>
-          <a:ln w="12700">
-            <a:solidFill>
-              <a:srgbClr val="D8D0C0"/>
-            </a:solidFill>
-            <a:prstDash val="solid"/>
-          </a:ln>
-        </p:spPr>
-      </p:sp>
-      <p:sp>
-        <p:nvSpPr>
-          <p:cNvPr id="22" name="Text 20"/>
-          <p:cNvSpPr/>
-          <p:nvPr/>
-        </p:nvSpPr>
-        <p:spPr>
-          <a:xfrm>
-            <a:off x="530352" y="3300984"/>
-            <a:ext cx="1417320" cy="658368"/>
-          </a:xfrm>
-          <a:prstGeom prst="rect">
-            <a:avLst/>
-          </a:prstGeom>
-          <a:noFill/>
-          <a:ln/>
-        </p:spPr>
-        <p:txBody>
-          <a:bodyPr wrap="square" lIns="0" tIns="0" rIns="0" bIns="0" rtlCol="0" anchor="ctr"/>
-          <a:lstStyle/>
-          <a:p>
-            <a:pPr algn="ctr" indent="0" marL="0">
-              <a:buNone/>
-            </a:pPr>
-            <a:r>
-              <a:rPr lang="en-US" sz="1100" b="1" dirty="0">
-                <a:solidFill>
-                  <a:srgbClr val="1A1A1A"/>
-                </a:solidFill>
-              </a:rPr>
-              <a:t>Week 3</a:t>
-            </a:r>
-            <a:endParaRPr lang="en-US" sz="1100" dirty="0"/>
-          </a:p>
-          <a:p>
-            <a:pPr algn="ctr" indent="0" marL="0">
-              <a:buNone/>
-            </a:pPr>
-            <a:r>
-              <a:rPr lang="en-US" sz="1100" b="1" dirty="0">
-                <a:solidFill>
-                  <a:srgbClr val="1A1A1A"/>
-                </a:solidFill>
-              </a:rPr>
-              <a:t>Apr 1</a:t>
-            </a:r>
-            <a:endParaRPr lang="en-US" sz="1100" dirty="0"/>
-          </a:p>
-        </p:txBody>
-      </p:sp>
-      <p:sp>
-        <p:nvSpPr>
-          <p:cNvPr id="23" name="Text 21"/>
-          <p:cNvSpPr/>
-          <p:nvPr/>
-        </p:nvSpPr>
-        <p:spPr>
-          <a:xfrm>
-            <a:off x="2121408" y="3328416"/>
-            <a:ext cx="3200400" cy="658368"/>
-          </a:xfrm>
-          <a:prstGeom prst="rect">
-            <a:avLst/>
-          </a:prstGeom>
-          <a:noFill/>
-          <a:ln/>
-        </p:spPr>
-        <p:txBody>
-          <a:bodyPr wrap="square" lIns="0" tIns="0" rIns="0" bIns="0" rtlCol="0" anchor="ctr"/>
-          <a:lstStyle/>
-          <a:p>
-            <a:pPr indent="0" marL="0">
-              <a:buNone/>
-            </a:pPr>
-            <a:r>
-              <a:rPr lang="en-US" sz="1100" dirty="0">
-                <a:solidFill>
-                  <a:srgbClr val="4A4A4A"/>
-                </a:solidFill>
-              </a:rPr>
-              <a:t>Fine-tune BERT;</a:t>
-            </a:r>
-            <a:endParaRPr lang="en-US" sz="1100" dirty="0"/>
-          </a:p>
-          <a:p>
-            <a:pPr indent="0" marL="0">
-              <a:buNone/>
-            </a:pPr>
-            <a:r>
-              <a:rPr lang="en-US" sz="1100" dirty="0">
-                <a:solidFill>
-                  <a:srgbClr val="4A4A4A"/>
-                </a:solidFill>
-              </a:rPr>
-              <a:t>compare vs baseline</a:t>
-            </a:r>
-            <a:endParaRPr lang="en-US" sz="1100" dirty="0"/>
-          </a:p>
-        </p:txBody>
-      </p:sp>
-      <p:sp>
-        <p:nvSpPr>
-          <p:cNvPr id="24" name="Shape 22"/>
-          <p:cNvSpPr/>
-          <p:nvPr/>
-        </p:nvSpPr>
-        <p:spPr>
-          <a:xfrm>
-            <a:off x="5047488" y="3483864"/>
-            <a:ext cx="347472" cy="292608"/>
-          </a:xfrm>
-          <a:prstGeom prst="rect">
-            <a:avLst/>
-          </a:prstGeom>
-          <a:solidFill>
-            <a:srgbClr val="555555"/>
-          </a:solidFill>
-          <a:ln w="12700">
-            <a:solidFill>
-              <a:srgbClr val="555555"/>
-            </a:solidFill>
-            <a:prstDash val="solid"/>
-          </a:ln>
-        </p:spPr>
-      </p:sp>
-      <p:sp>
-        <p:nvSpPr>
-          <p:cNvPr id="25" name="Text 23"/>
-          <p:cNvSpPr/>
-          <p:nvPr/>
-        </p:nvSpPr>
-        <p:spPr>
-          <a:xfrm>
-            <a:off x="5047488" y="3483864"/>
-            <a:ext cx="347472" cy="292608"/>
-          </a:xfrm>
-          <a:prstGeom prst="rect">
-            <a:avLst/>
-          </a:prstGeom>
-          <a:noFill/>
-          <a:ln/>
-        </p:spPr>
-        <p:txBody>
-          <a:bodyPr wrap="square" lIns="0" tIns="0" rIns="0" bIns="0" rtlCol="0" anchor="ctr"/>
-          <a:lstStyle/>
-          <a:p>
-            <a:pPr algn="ctr" indent="0" marL="0">
-              <a:buNone/>
-            </a:pPr>
-            <a:r>
-              <a:rPr lang="en-US" sz="600" b="1" dirty="0">
-                <a:solidFill>
-                  <a:srgbClr val="FFFFFF"/>
-                </a:solidFill>
-              </a:rPr>
-              <a:t>ON TRACK</a:t>
-            </a:r>
-            <a:endParaRPr lang="en-US" sz="600" dirty="0"/>
-          </a:p>
-        </p:txBody>
-      </p:sp>
-      <p:sp>
-        <p:nvSpPr>
-          <p:cNvPr id="26" name="Text 24"/>
-          <p:cNvSpPr/>
-          <p:nvPr/>
-        </p:nvSpPr>
-        <p:spPr>
-          <a:xfrm>
-            <a:off x="5532120" y="3264408"/>
-            <a:ext cx="3017520" cy="722376"/>
-          </a:xfrm>
-          <a:prstGeom prst="rect">
-            <a:avLst/>
-          </a:prstGeom>
-          <a:noFill/>
-          <a:ln/>
-        </p:spPr>
-        <p:txBody>
-          <a:bodyPr wrap="square" rtlCol="0" anchor="ctr"/>
-          <a:lstStyle/>
-          <a:p>
-            <a:pPr marL="342900" indent="-342900">
-              <a:spcAft>
-                <a:spcPts val="100"/>
-              </a:spcAft>
-              <a:buSzPct val="100000"/>
-              <a:buChar char="•"/>
-            </a:pPr>
-            <a:r>
-              <a:rPr lang="en-US" sz="1050" b="1" dirty="0">
-                <a:solidFill>
-                  <a:srgbClr val="1A1A1A"/>
-                </a:solidFill>
-              </a:rPr>
-              <a:t>Apr 1 — Evaluation &amp; error analysis added</a:t>
-            </a:r>
-            <a:endParaRPr lang="en-US" sz="1050" dirty="0"/>
-          </a:p>
-          <a:p>
-            <a:pPr indent="0" marL="0">
-              <a:buNone/>
-            </a:pPr>
-            <a:r>
-              <a:rPr lang="en-US" sz="950" dirty="0">
-                <a:solidFill>
-                  <a:srgbClr val="888888"/>
-                </a:solidFill>
-              </a:rPr>
-              <a:t>BBC test accuracy: ~97.8% (baseline)</a:t>
-            </a:r>
-            <a:endParaRPr lang="en-US" sz="1050" dirty="0"/>
-          </a:p>
-          <a:p>
-            <a:pPr indent="0" marL="0">
-              <a:buNone/>
-            </a:pPr>
-            <a:r>
-              <a:rPr lang="en-US" sz="950" dirty="0">
-                <a:solidFill>
-                  <a:srgbClr val="888888"/>
-                </a:solidFill>
-              </a:rPr>
-              <a:t>Results solid — but dataset felt too small</a:t>
-            </a:r>
-            <a:endParaRPr lang="en-US" sz="1050" dirty="0"/>
-          </a:p>
-        </p:txBody>
-      </p:sp>
-      <p:sp>
-        <p:nvSpPr>
-          <p:cNvPr id="27" name="Shape 25"/>
-          <p:cNvSpPr/>
-          <p:nvPr/>
-        </p:nvSpPr>
-        <p:spPr>
-          <a:xfrm>
-            <a:off x="457200" y="4123944"/>
-            <a:ext cx="8229600" cy="868680"/>
-          </a:xfrm>
-          <a:prstGeom prst="rect">
-            <a:avLst/>
-          </a:prstGeom>
-          <a:solidFill>
-            <a:srgbClr val="F5F0E8"/>
-          </a:solidFill>
-          <a:ln w="12700">
-            <a:solidFill>
-              <a:srgbClr val="D8D0C0"/>
-            </a:solidFill>
-            <a:prstDash val="solid"/>
-          </a:ln>
-        </p:spPr>
-      </p:sp>
-      <p:sp>
-        <p:nvSpPr>
-          <p:cNvPr id="28" name="Text 26"/>
-          <p:cNvSpPr/>
-          <p:nvPr/>
-        </p:nvSpPr>
-        <p:spPr>
-          <a:xfrm>
-            <a:off x="530352" y="4233672"/>
-            <a:ext cx="1417320" cy="658368"/>
-          </a:xfrm>
-          <a:prstGeom prst="rect">
-            <a:avLst/>
-          </a:prstGeom>
-          <a:noFill/>
-          <a:ln/>
-        </p:spPr>
-        <p:txBody>
-          <a:bodyPr wrap="square" lIns="0" tIns="0" rIns="0" bIns="0" rtlCol="0" anchor="ctr"/>
-          <a:lstStyle/>
-          <a:p>
-            <a:pPr algn="ctr" indent="0" marL="0">
-              <a:buNone/>
-            </a:pPr>
-            <a:r>
-              <a:rPr lang="en-US" sz="1100" b="1" dirty="0">
-                <a:solidFill>
-                  <a:srgbClr val="1A1A1A"/>
-                </a:solidFill>
-              </a:rPr>
-              <a:t>Week 4</a:t>
-            </a:r>
-            <a:endParaRPr lang="en-US" sz="1100" dirty="0"/>
-          </a:p>
-          <a:p>
-            <a:pPr algn="ctr" indent="0" marL="0">
-              <a:buNone/>
-            </a:pPr>
-            <a:r>
-              <a:rPr lang="en-US" sz="1100" b="1" dirty="0">
-                <a:solidFill>
-                  <a:srgbClr val="1A1A1A"/>
-                </a:solidFill>
-              </a:rPr>
-              <a:t>Apr 4–5</a:t>
-            </a:r>
-            <a:endParaRPr lang="en-US" sz="1100" dirty="0"/>
-          </a:p>
-        </p:txBody>
-      </p:sp>
-      <p:sp>
-        <p:nvSpPr>
-          <p:cNvPr id="29" name="Text 27"/>
-          <p:cNvSpPr/>
-          <p:nvPr/>
-        </p:nvSpPr>
-        <p:spPr>
-          <a:xfrm>
-            <a:off x="2121408" y="4261104"/>
-            <a:ext cx="3200400" cy="658368"/>
-          </a:xfrm>
-          <a:prstGeom prst="rect">
-            <a:avLst/>
-          </a:prstGeom>
-          <a:noFill/>
-          <a:ln/>
-        </p:spPr>
-        <p:txBody>
-          <a:bodyPr wrap="square" lIns="0" tIns="0" rIns="0" bIns="0" rtlCol="0" anchor="ctr"/>
-          <a:lstStyle/>
-          <a:p>
-            <a:pPr indent="0" marL="0">
-              <a:buNone/>
-            </a:pPr>
-            <a:r>
-              <a:rPr lang="en-US" sz="1100" dirty="0">
-                <a:solidFill>
-                  <a:srgbClr val="4A4A4A"/>
-                </a:solidFill>
-              </a:rPr>
-              <a:t>Error analysis,</a:t>
-            </a:r>
-            <a:endParaRPr lang="en-US" sz="1100" dirty="0"/>
-          </a:p>
-          <a:p>
-            <a:pPr indent="0" marL="0">
-              <a:buNone/>
-            </a:pPr>
-            <a:r>
-              <a:rPr lang="en-US" sz="1100" dirty="0">
-                <a:solidFill>
-                  <a:srgbClr val="4A4A4A"/>
-                </a:solidFill>
-              </a:rPr>
-              <a:t>findings, presentation</a:t>
-            </a:r>
-            <a:endParaRPr lang="en-US" sz="1100" dirty="0"/>
-          </a:p>
-        </p:txBody>
-      </p:sp>
-      <p:sp>
-        <p:nvSpPr>
-          <p:cNvPr id="30" name="Shape 28"/>
-          <p:cNvSpPr/>
-          <p:nvPr/>
-        </p:nvSpPr>
-        <p:spPr>
-          <a:xfrm>
-            <a:off x="5047488" y="4416552"/>
-            <a:ext cx="347472" cy="292608"/>
-          </a:xfrm>
-          <a:prstGeom prst="rect">
-            <a:avLst/>
-          </a:prstGeom>
-          <a:solidFill>
-            <a:srgbClr val="1A1A1A"/>
-          </a:solidFill>
-          <a:ln w="12700">
-            <a:solidFill>
-              <a:srgbClr val="1A1A1A"/>
-            </a:solidFill>
-            <a:prstDash val="solid"/>
-          </a:ln>
-        </p:spPr>
-      </p:sp>
-      <p:sp>
-        <p:nvSpPr>
-          <p:cNvPr id="31" name="Text 29"/>
-          <p:cNvSpPr/>
-          <p:nvPr/>
-        </p:nvSpPr>
-        <p:spPr>
-          <a:xfrm>
-            <a:off x="5047488" y="4416552"/>
-            <a:ext cx="347472" cy="292608"/>
-          </a:xfrm>
-          <a:prstGeom prst="rect">
-            <a:avLst/>
-          </a:prstGeom>
-          <a:noFill/>
-          <a:ln/>
-        </p:spPr>
-        <p:txBody>
-          <a:bodyPr wrap="square" lIns="0" tIns="0" rIns="0" bIns="0" rtlCol="0" anchor="ctr"/>
-          <a:lstStyle/>
-          <a:p>
-            <a:pPr algn="ctr" indent="0" marL="0">
-              <a:buNone/>
-            </a:pPr>
-            <a:r>
-              <a:rPr lang="en-US" sz="600" b="1" dirty="0">
-                <a:solidFill>
-                  <a:srgbClr val="FFFFFF"/>
-                </a:solidFill>
-              </a:rPr>
-              <a:t>EXPANDED</a:t>
-            </a:r>
-            <a:endParaRPr lang="en-US" sz="600" dirty="0"/>
-          </a:p>
-        </p:txBody>
-      </p:sp>
-      <p:sp>
-        <p:nvSpPr>
-          <p:cNvPr id="32" name="Text 30"/>
-          <p:cNvSpPr/>
-          <p:nvPr/>
-        </p:nvSpPr>
-        <p:spPr>
-          <a:xfrm>
-            <a:off x="5532120" y="4197096"/>
-            <a:ext cx="3017520" cy="722376"/>
-          </a:xfrm>
-          <a:prstGeom prst="rect">
-            <a:avLst/>
-          </a:prstGeom>
-          <a:noFill/>
-          <a:ln/>
-        </p:spPr>
-        <p:txBody>
-          <a:bodyPr wrap="square" rtlCol="0" anchor="ctr"/>
-          <a:lstStyle/>
-          <a:p>
-            <a:pPr marL="342900" indent="-342900">
-              <a:spcAft>
-                <a:spcPts val="100"/>
-              </a:spcAft>
-              <a:buSzPct val="100000"/>
-              <a:buChar char="•"/>
-            </a:pPr>
-            <a:r>
-              <a:rPr lang="en-US" sz="1050" b="1" dirty="0">
-                <a:solidFill>
-                  <a:srgbClr val="1A1A1A"/>
-                </a:solidFill>
-              </a:rPr>
-              <a:t>Apr 4 — Decided to add AG News</a:t>
-            </a:r>
-            <a:endParaRPr lang="en-US" sz="1050" dirty="0"/>
-          </a:p>
-          <a:p>
-            <a:pPr indent="0" marL="0">
-              <a:buNone/>
-            </a:pPr>
-            <a:r>
-              <a:rPr lang="en-US" sz="950" dirty="0">
-                <a:solidFill>
-                  <a:srgbClr val="888888"/>
-                </a:solidFill>
-              </a:rPr>
-              <a:t>Thomas migrated pipeline; Ruoxuan + Xinyan</a:t>
-            </a:r>
-            <a:endParaRPr lang="en-US" sz="1050" dirty="0"/>
-          </a:p>
-          <a:p>
-            <a:pPr indent="0" marL="0">
-              <a:buNone/>
-            </a:pPr>
-            <a:r>
-              <a:rPr lang="en-US" sz="950" dirty="0">
-                <a:solidFill>
-                  <a:srgbClr val="888888"/>
-                </a:solidFill>
-              </a:rPr>
-              <a:t>updated their scripts within 2 days</a:t>
-            </a:r>
-            <a:endParaRPr lang="en-US" sz="1050" dirty="0"/>
-          </a:p>
-        </p:txBody>
-      </p:sp>
-      <p:sp>
-        <p:nvSpPr>
-          <p:cNvPr id="33" name="Shape 31"/>
-          <p:cNvSpPr/>
-          <p:nvPr/>
-        </p:nvSpPr>
-        <p:spPr>
-          <a:xfrm>
-            <a:off x="457200" y="4663440"/>
-            <a:ext cx="8229600" cy="164592"/>
-          </a:xfrm>
-          <a:prstGeom prst="rect">
-            <a:avLst/>
-          </a:prstGeom>
-          <a:solidFill>
-            <a:srgbClr val="1A1A1A"/>
-          </a:solidFill>
-          <a:ln w="12700">
-            <a:solidFill>
-              <a:srgbClr val="1A1A1A"/>
-            </a:solidFill>
-            <a:prstDash val="solid"/>
-          </a:ln>
-        </p:spPr>
-      </p:sp>
-      <p:sp>
-        <p:nvSpPr>
-          <p:cNvPr id="34" name="Text 32"/>
-          <p:cNvSpPr/>
-          <p:nvPr/>
-        </p:nvSpPr>
-        <p:spPr>
-          <a:xfrm>
-            <a:off x="530352" y="4672584"/>
-            <a:ext cx="8092440" cy="155448"/>
-          </a:xfrm>
-          <a:prstGeom prst="rect">
-            <a:avLst/>
-          </a:prstGeom>
-          <a:noFill/>
-          <a:ln/>
-        </p:spPr>
-        <p:txBody>
-          <a:bodyPr wrap="square" lIns="0" tIns="0" rIns="0" bIns="0" rtlCol="0" anchor="ctr"/>
-          <a:lstStyle/>
-          <a:p>
-            <a:pPr algn="l" indent="0" marL="0">
-              <a:buNone/>
-            </a:pPr>
-            <a:r>
-              <a:rPr lang="en-US" sz="850" dirty="0">
-                <a:solidFill>
-                  <a:srgbClr val="CCCCCC"/>
-                </a:solidFill>
-              </a:rPr>
-              <a:t>Week 4 change: BBC ran with ~97.8% test accuracy — but 1,194 articles felt too small for a meaningful BERT comparison. Team decided to also run AG News (127.6k) for a more rigorous benchmark.</a:t>
-            </a:r>
-            <a:endParaRPr lang="en-US" sz="850" dirty="0"/>
-          </a:p>
-        </p:txBody>
-      </p:sp>
-      <p:sp>
-        <p:nvSpPr>
-          <p:cNvPr id="35" name="Shape 33"/>
-          <p:cNvSpPr/>
-          <p:nvPr/>
-        </p:nvSpPr>
-        <p:spPr>
-          <a:xfrm>
-            <a:off x="0" y="4818888"/>
-            <a:ext cx="9144000" cy="324612"/>
-          </a:xfrm>
-          <a:prstGeom prst="rect">
-            <a:avLst/>
-          </a:prstGeom>
-          <a:solidFill>
-            <a:srgbClr val="1A1A1A"/>
-          </a:solidFill>
-          <a:ln w="12700">
-            <a:solidFill>
-              <a:srgbClr val="1A1A1A"/>
-            </a:solidFill>
-            <a:prstDash val="solid"/>
-          </a:ln>
-        </p:spPr>
-      </p:sp>
-      <p:sp>
-        <p:nvSpPr>
-          <p:cNvPr id="36" name="Text 34"/>
-          <p:cNvSpPr/>
-          <p:nvPr/>
-        </p:nvSpPr>
-        <p:spPr>
-          <a:xfrm>
-            <a:off x="274320" y="4828032"/>
-            <a:ext cx="8595360" cy="301752"/>
-          </a:xfrm>
-          <a:prstGeom prst="rect">
-            <a:avLst/>
-          </a:prstGeom>
-          <a:noFill/>
-          <a:ln/>
-        </p:spPr>
-        <p:txBody>
-          <a:bodyPr wrap="square" lIns="0" tIns="0" rIns="0" bIns="0" rtlCol="0" anchor="ctr"/>
-          <a:lstStyle/>
-          <a:p>
-            <a:pPr algn="l" indent="0" marL="0">
-              <a:buNone/>
-            </a:pPr>
-            <a:r>
-              <a:rPr lang="en-US" sz="900" dirty="0">
-                <a:solidFill>
-                  <a:srgbClr val="AAAAAA"/>
-                </a:solidFill>
-              </a:rPr>
-              <a:t>Ming-Hsiang Lee  ·  Data Pipeline &amp; Preprocessing  ·  News Topic Classification  ·  Group 2</a:t>
+              <a:t>Week 4: BBC ran at ~97.8% test accuracy, but 1,194 articles was too small for a meaningful BERT benchmark. Team added AG News (127.6k) for a more rigorous comparison.</a:t>
             </a:r>
             <a:endParaRPr lang="en-US" sz="900" dirty="0"/>
           </a:p>
@@ -4192,7 +4085,7 @@
         <p:spPr>
           <a:xfrm>
             <a:off x="457200" y="914400"/>
-            <a:ext cx="3931920" cy="3611880"/>
+            <a:ext cx="3931920" cy="3977640"/>
           </a:xfrm>
           <a:prstGeom prst="rect">
             <a:avLst/>
@@ -4260,7 +4153,7 @@
         <p:spPr>
           <a:xfrm>
             <a:off x="594360" y="1508760"/>
-            <a:ext cx="3566160" cy="2651760"/>
+            <a:ext cx="3566160" cy="3017520"/>
           </a:xfrm>
           <a:prstGeom prst="rect">
             <a:avLst/>
@@ -4390,7 +4283,7 @@
         <p:spPr>
           <a:xfrm>
             <a:off x="4663440" y="914400"/>
-            <a:ext cx="4023360" cy="3611880"/>
+            <a:ext cx="4023360" cy="3977640"/>
           </a:xfrm>
           <a:prstGeom prst="rect">
             <a:avLst/>
@@ -4458,7 +4351,7 @@
         <p:spPr>
           <a:xfrm>
             <a:off x="4800600" y="1508760"/>
-            <a:ext cx="3657600" cy="2651760"/>
+            <a:ext cx="3657600" cy="3017520"/>
           </a:xfrm>
           <a:prstGeom prst="rect">
             <a:avLst/>
@@ -4594,92 +4487,6 @@
               <a:t>val carved from train (85 / 15)</a:t>
             </a:r>
             <a:endParaRPr lang="en-US" sz="1200" dirty="0"/>
-          </a:p>
-        </p:txBody>
-      </p:sp>
-      <p:sp>
-        <p:nvSpPr>
-          <p:cNvPr id="9" name="Shape 7"/>
-          <p:cNvSpPr/>
-          <p:nvPr/>
-        </p:nvSpPr>
-        <p:spPr>
-          <a:xfrm>
-            <a:off x="4663440" y="4544568"/>
-            <a:ext cx="4023360" cy="0"/>
-          </a:xfrm>
-          <a:prstGeom prst="rect">
-            <a:avLst/>
-          </a:prstGeom>
-          <a:solidFill>
-            <a:srgbClr val="F5F0E8"/>
-          </a:solidFill>
-          <a:ln w="12700">
-            <a:solidFill>
-              <a:srgbClr val="F5F0E8"/>
-            </a:solidFill>
-            <a:prstDash val="solid"/>
-          </a:ln>
-        </p:spPr>
-      </p:sp>
-      <p:sp>
-        <p:nvSpPr>
-          <p:cNvPr id="10" name="Shape 8"/>
-          <p:cNvSpPr/>
-          <p:nvPr/>
-        </p:nvSpPr>
-        <p:spPr>
-          <a:xfrm>
-            <a:off x="0" y="4818888"/>
-            <a:ext cx="9144000" cy="324612"/>
-          </a:xfrm>
-          <a:prstGeom prst="rect">
-            <a:avLst/>
-          </a:prstGeom>
-          <a:solidFill>
-            <a:srgbClr val="1A1A1A"/>
-          </a:solidFill>
-          <a:ln w="12700">
-            <a:solidFill>
-              <a:srgbClr val="1A1A1A"/>
-            </a:solidFill>
-            <a:prstDash val="solid"/>
-          </a:ln>
-        </p:spPr>
-      </p:sp>
-      <p:sp>
-        <p:nvSpPr>
-          <p:cNvPr id="11" name="Text 9"/>
-          <p:cNvSpPr/>
-          <p:nvPr/>
-        </p:nvSpPr>
-        <p:spPr>
-          <a:xfrm>
-            <a:off x="274320" y="4828032"/>
-            <a:ext cx="8595360" cy="301752"/>
-          </a:xfrm>
-          <a:prstGeom prst="rect">
-            <a:avLst/>
-          </a:prstGeom>
-          <a:noFill/>
-          <a:ln/>
-        </p:spPr>
-        <p:txBody>
-          <a:bodyPr wrap="square" lIns="0" tIns="0" rIns="0" bIns="0" rtlCol="0" anchor="ctr"/>
-          <a:lstStyle/>
-          <a:p>
-            <a:pPr algn="l" indent="0" marL="0">
-              <a:buNone/>
-            </a:pPr>
-            <a:r>
-              <a:rPr lang="en-US" sz="900" dirty="0">
-                <a:solidFill>
-                  <a:srgbClr val="AAAAAA"/>
-                </a:solidFill>
-              </a:rPr>
-              <a:t>Ming-Hsiang Lee  ·  Data Pipeline &amp; Preprocessing  ·  News Topic Classification  ·  Group 2</a:t>
-            </a:r>
-            <a:endParaRPr lang="en-US" sz="900" dirty="0"/>
           </a:p>
         </p:txBody>
       </p:sp>
@@ -5789,7 +5596,7 @@
         </p:nvSpPr>
         <p:spPr>
           <a:xfrm>
-            <a:off x="457200" y="4645152"/>
+            <a:off x="457200" y="4681728"/>
             <a:ext cx="8229600" cy="201168"/>
           </a:xfrm>
           <a:prstGeom prst="rect">
@@ -5814,67 +5621,6 @@
               <a:t>random_state = 42 throughout — fully reproducible splits every run</a:t>
             </a:r>
             <a:endParaRPr lang="en-US" sz="1000" dirty="0"/>
-          </a:p>
-        </p:txBody>
-      </p:sp>
-      <p:sp>
-        <p:nvSpPr>
-          <p:cNvPr id="36" name="Shape 34"/>
-          <p:cNvSpPr/>
-          <p:nvPr/>
-        </p:nvSpPr>
-        <p:spPr>
-          <a:xfrm>
-            <a:off x="0" y="4818888"/>
-            <a:ext cx="9144000" cy="324612"/>
-          </a:xfrm>
-          <a:prstGeom prst="rect">
-            <a:avLst/>
-          </a:prstGeom>
-          <a:solidFill>
-            <a:srgbClr val="1A1A1A"/>
-          </a:solidFill>
-          <a:ln w="12700">
-            <a:solidFill>
-              <a:srgbClr val="1A1A1A"/>
-            </a:solidFill>
-            <a:prstDash val="solid"/>
-          </a:ln>
-        </p:spPr>
-      </p:sp>
-      <p:sp>
-        <p:nvSpPr>
-          <p:cNvPr id="37" name="Text 35"/>
-          <p:cNvSpPr/>
-          <p:nvPr/>
-        </p:nvSpPr>
-        <p:spPr>
-          <a:xfrm>
-            <a:off x="274320" y="4828032"/>
-            <a:ext cx="8595360" cy="301752"/>
-          </a:xfrm>
-          <a:prstGeom prst="rect">
-            <a:avLst/>
-          </a:prstGeom>
-          <a:noFill/>
-          <a:ln/>
-        </p:spPr>
-        <p:txBody>
-          <a:bodyPr wrap="square" lIns="0" tIns="0" rIns="0" bIns="0" rtlCol="0" anchor="ctr"/>
-          <a:lstStyle/>
-          <a:p>
-            <a:pPr algn="l" indent="0" marL="0">
-              <a:buNone/>
-            </a:pPr>
-            <a:r>
-              <a:rPr lang="en-US" sz="900" dirty="0">
-                <a:solidFill>
-                  <a:srgbClr val="AAAAAA"/>
-                </a:solidFill>
-              </a:rPr>
-              <a:t>Ming-Hsiang Lee  ·  Data Pipeline &amp; Preprocessing  ·  News Topic Classification  ·  Group 2</a:t>
-            </a:r>
-            <a:endParaRPr lang="en-US" sz="900" dirty="0"/>
           </a:p>
         </p:txBody>
       </p:sp>
@@ -7284,7 +7030,7 @@
         <p:spPr>
           <a:xfrm>
             <a:off x="457200" y="3337560"/>
-            <a:ext cx="3931920" cy="1234440"/>
+            <a:ext cx="3931920" cy="1417320"/>
           </a:xfrm>
           <a:prstGeom prst="rect">
             <a:avLst/>
@@ -7377,7 +7123,7 @@
         <p:spPr>
           <a:xfrm>
             <a:off x="594360" y="3749040"/>
-            <a:ext cx="3611880" cy="777240"/>
+            <a:ext cx="3611880" cy="914400"/>
           </a:xfrm>
           <a:prstGeom prst="rect">
             <a:avLst/>
@@ -7467,7 +7213,7 @@
         <p:spPr>
           <a:xfrm>
             <a:off x="4526280" y="3337560"/>
-            <a:ext cx="4160520" cy="1234440"/>
+            <a:ext cx="4160520" cy="1417320"/>
           </a:xfrm>
           <a:prstGeom prst="rect">
             <a:avLst/>
@@ -7560,7 +7306,7 @@
         <p:spPr>
           <a:xfrm>
             <a:off x="4663440" y="3749040"/>
-            <a:ext cx="3886200" cy="777240"/>
+            <a:ext cx="3886200" cy="914400"/>
           </a:xfrm>
           <a:prstGeom prst="rect">
             <a:avLst/>
@@ -7627,67 +7373,6 @@
               <a:t># ID_TO_LABEL: {0: 'business', 3: 'sport', ...}</a:t>
             </a:r>
             <a:endParaRPr lang="en-US" sz="950" dirty="0"/>
-          </a:p>
-        </p:txBody>
-      </p:sp>
-      <p:sp>
-        <p:nvSpPr>
-          <p:cNvPr id="13" name="Shape 10"/>
-          <p:cNvSpPr/>
-          <p:nvPr/>
-        </p:nvSpPr>
-        <p:spPr>
-          <a:xfrm>
-            <a:off x="0" y="4818888"/>
-            <a:ext cx="9144000" cy="324612"/>
-          </a:xfrm>
-          <a:prstGeom prst="rect">
-            <a:avLst/>
-          </a:prstGeom>
-          <a:solidFill>
-            <a:srgbClr val="1A1A1A"/>
-          </a:solidFill>
-          <a:ln w="12700">
-            <a:solidFill>
-              <a:srgbClr val="1A1A1A"/>
-            </a:solidFill>
-            <a:prstDash val="solid"/>
-          </a:ln>
-        </p:spPr>
-      </p:sp>
-      <p:sp>
-        <p:nvSpPr>
-          <p:cNvPr id="14" name="Text 11"/>
-          <p:cNvSpPr/>
-          <p:nvPr/>
-        </p:nvSpPr>
-        <p:spPr>
-          <a:xfrm>
-            <a:off x="274320" y="4828032"/>
-            <a:ext cx="8595360" cy="301752"/>
-          </a:xfrm>
-          <a:prstGeom prst="rect">
-            <a:avLst/>
-          </a:prstGeom>
-          <a:noFill/>
-          <a:ln/>
-        </p:spPr>
-        <p:txBody>
-          <a:bodyPr wrap="square" lIns="0" tIns="0" rIns="0" bIns="0" rtlCol="0" anchor="ctr"/>
-          <a:lstStyle/>
-          <a:p>
-            <a:pPr algn="l" indent="0" marL="0">
-              <a:buNone/>
-            </a:pPr>
-            <a:r>
-              <a:rPr lang="en-US" sz="900" dirty="0">
-                <a:solidFill>
-                  <a:srgbClr val="AAAAAA"/>
-                </a:solidFill>
-              </a:rPr>
-              <a:t>Ming-Hsiang Lee  ·  Data Pipeline &amp; Preprocessing  ·  News Topic Classification  ·  Group 2</a:t>
-            </a:r>
-            <a:endParaRPr lang="en-US" sz="900" dirty="0"/>
           </a:p>
         </p:txBody>
       </p:sp>
@@ -8535,67 +8220,6 @@
           </a:p>
         </p:txBody>
       </p:sp>
-      <p:sp>
-        <p:nvSpPr>
-          <p:cNvPr id="24" name="Shape 22"/>
-          <p:cNvSpPr/>
-          <p:nvPr/>
-        </p:nvSpPr>
-        <p:spPr>
-          <a:xfrm>
-            <a:off x="0" y="4818888"/>
-            <a:ext cx="9144000" cy="324612"/>
-          </a:xfrm>
-          <a:prstGeom prst="rect">
-            <a:avLst/>
-          </a:prstGeom>
-          <a:solidFill>
-            <a:srgbClr val="1A1A1A"/>
-          </a:solidFill>
-          <a:ln w="12700">
-            <a:solidFill>
-              <a:srgbClr val="1A1A1A"/>
-            </a:solidFill>
-            <a:prstDash val="solid"/>
-          </a:ln>
-        </p:spPr>
-      </p:sp>
-      <p:sp>
-        <p:nvSpPr>
-          <p:cNvPr id="25" name="Text 23"/>
-          <p:cNvSpPr/>
-          <p:nvPr/>
-        </p:nvSpPr>
-        <p:spPr>
-          <a:xfrm>
-            <a:off x="274320" y="4828032"/>
-            <a:ext cx="8595360" cy="301752"/>
-          </a:xfrm>
-          <a:prstGeom prst="rect">
-            <a:avLst/>
-          </a:prstGeom>
-          <a:noFill/>
-          <a:ln/>
-        </p:spPr>
-        <p:txBody>
-          <a:bodyPr wrap="square" lIns="0" tIns="0" rIns="0" bIns="0" rtlCol="0" anchor="ctr"/>
-          <a:lstStyle/>
-          <a:p>
-            <a:pPr algn="l" indent="0" marL="0">
-              <a:buNone/>
-            </a:pPr>
-            <a:r>
-              <a:rPr lang="en-US" sz="900" dirty="0">
-                <a:solidFill>
-                  <a:srgbClr val="AAAAAA"/>
-                </a:solidFill>
-              </a:rPr>
-              <a:t>Ming-Hsiang Lee  ·  Data Pipeline &amp; Preprocessing  ·  News Topic Classification  ·  Group 2</a:t>
-            </a:r>
-            <a:endParaRPr lang="en-US" sz="900" dirty="0"/>
-          </a:p>
-        </p:txBody>
-      </p:sp>
     </p:spTree>
   </p:cSld>
   <p:clrMapOvr>
@@ -8676,7 +8300,7 @@
         <p:spPr>
           <a:xfrm>
             <a:off x="457200" y="914400"/>
-            <a:ext cx="4572000" cy="3657600"/>
+            <a:ext cx="4572000" cy="3977640"/>
           </a:xfrm>
           <a:prstGeom prst="rect">
             <a:avLst/>
@@ -8707,24 +8331,24 @@
         </p:nvSpPr>
         <p:spPr>
           <a:xfrm>
-            <a:off x="594360" y="1005840"/>
-            <a:ext cx="4297680" cy="201168"/>
-          </a:xfrm>
-          <a:prstGeom prst="rect">
-            <a:avLst/>
-          </a:prstGeom>
-          <a:noFill/>
-          <a:ln/>
-        </p:spPr>
-        <p:txBody>
-          <a:bodyPr wrap="square" lIns="0" tIns="0" rIns="0" bIns="0" rtlCol="0" anchor="ctr"/>
-          <a:lstStyle/>
-          <a:p>
-            <a:pPr indent="0" marL="0">
-              <a:buNone/>
-            </a:pPr>
-            <a:r>
-              <a:rPr lang="en-US" sz="900" b="1" dirty="0">
+            <a:off x="594360" y="1024128"/>
+            <a:ext cx="4297680" cy="228600"/>
+          </a:xfrm>
+          <a:prstGeom prst="rect">
+            <a:avLst/>
+          </a:prstGeom>
+          <a:noFill/>
+          <a:ln/>
+        </p:spPr>
+        <p:txBody>
+          <a:bodyPr wrap="square" lIns="0" tIns="0" rIns="0" bIns="0" rtlCol="0" anchor="ctr"/>
+          <a:lstStyle/>
+          <a:p>
+            <a:pPr indent="0" marL="0">
+              <a:buNone/>
+            </a:pPr>
+            <a:r>
+              <a:rPr lang="en-US" sz="950" b="1" dirty="0">
                 <a:solidFill>
                   <a:srgbClr val="F5C842"/>
                 </a:solidFill>
@@ -8734,7 +8358,7 @@
               </a:rPr>
               <a:t>data/</a:t>
             </a:r>
-            <a:endParaRPr lang="en-US" sz="900" dirty="0"/>
+            <a:endParaRPr lang="en-US" sz="950" dirty="0"/>
           </a:p>
         </p:txBody>
       </p:sp>
@@ -8746,24 +8370,24 @@
         </p:nvSpPr>
         <p:spPr>
           <a:xfrm>
-            <a:off x="594360" y="1202436"/>
-            <a:ext cx="4297680" cy="201168"/>
-          </a:xfrm>
-          <a:prstGeom prst="rect">
-            <a:avLst/>
-          </a:prstGeom>
-          <a:noFill/>
-          <a:ln/>
-        </p:spPr>
-        <p:txBody>
-          <a:bodyPr wrap="square" lIns="0" tIns="0" rIns="0" bIns="0" rtlCol="0" anchor="ctr"/>
-          <a:lstStyle/>
-          <a:p>
-            <a:pPr indent="0" marL="0">
-              <a:buNone/>
-            </a:pPr>
-            <a:r>
-              <a:rPr lang="en-US" sz="900" dirty="0">
+            <a:off x="594360" y="1248156"/>
+            <a:ext cx="4297680" cy="228600"/>
+          </a:xfrm>
+          <a:prstGeom prst="rect">
+            <a:avLst/>
+          </a:prstGeom>
+          <a:noFill/>
+          <a:ln/>
+        </p:spPr>
+        <p:txBody>
+          <a:bodyPr wrap="square" lIns="0" tIns="0" rIns="0" bIns="0" rtlCol="0" anchor="ctr"/>
+          <a:lstStyle/>
+          <a:p>
+            <a:pPr indent="0" marL="0">
+              <a:buNone/>
+            </a:pPr>
+            <a:r>
+              <a:rPr lang="en-US" sz="950" dirty="0">
                 <a:solidFill>
                   <a:srgbClr val="90CAF9"/>
                 </a:solidFill>
@@ -8773,7 +8397,7 @@
               </a:rPr>
               <a:t>├── raw/</a:t>
             </a:r>
-            <a:endParaRPr lang="en-US" sz="900" dirty="0"/>
+            <a:endParaRPr lang="en-US" sz="950" dirty="0"/>
           </a:p>
         </p:txBody>
       </p:sp>
@@ -8785,24 +8409,24 @@
         </p:nvSpPr>
         <p:spPr>
           <a:xfrm>
-            <a:off x="594360" y="1399032"/>
-            <a:ext cx="4297680" cy="201168"/>
-          </a:xfrm>
-          <a:prstGeom prst="rect">
-            <a:avLst/>
-          </a:prstGeom>
-          <a:noFill/>
-          <a:ln/>
-        </p:spPr>
-        <p:txBody>
-          <a:bodyPr wrap="square" lIns="0" tIns="0" rIns="0" bIns="0" rtlCol="0" anchor="ctr"/>
-          <a:lstStyle/>
-          <a:p>
-            <a:pPr indent="0" marL="0">
-              <a:buNone/>
-            </a:pPr>
-            <a:r>
-              <a:rPr lang="en-US" sz="900" dirty="0">
+            <a:off x="594360" y="1472184"/>
+            <a:ext cx="4297680" cy="228600"/>
+          </a:xfrm>
+          <a:prstGeom prst="rect">
+            <a:avLst/>
+          </a:prstGeom>
+          <a:noFill/>
+          <a:ln/>
+        </p:spPr>
+        <p:txBody>
+          <a:bodyPr wrap="square" lIns="0" tIns="0" rIns="0" bIns="0" rtlCol="0" anchor="ctr"/>
+          <a:lstStyle/>
+          <a:p>
+            <a:pPr indent="0" marL="0">
+              <a:buNone/>
+            </a:pPr>
+            <a:r>
+              <a:rPr lang="en-US" sz="950" dirty="0">
                 <a:solidFill>
                   <a:srgbClr val="FFFFFF"/>
                 </a:solidFill>
@@ -8812,7 +8436,7 @@
               </a:rPr>
               <a:t>│   ├── bbc-text.csv</a:t>
             </a:r>
-            <a:endParaRPr lang="en-US" sz="900" dirty="0"/>
+            <a:endParaRPr lang="en-US" sz="950" dirty="0"/>
           </a:p>
         </p:txBody>
       </p:sp>
@@ -8824,24 +8448,24 @@
         </p:nvSpPr>
         <p:spPr>
           <a:xfrm>
-            <a:off x="594360" y="1595628"/>
-            <a:ext cx="4297680" cy="201168"/>
-          </a:xfrm>
-          <a:prstGeom prst="rect">
-            <a:avLst/>
-          </a:prstGeom>
-          <a:noFill/>
-          <a:ln/>
-        </p:spPr>
-        <p:txBody>
-          <a:bodyPr wrap="square" lIns="0" tIns="0" rIns="0" bIns="0" rtlCol="0" anchor="ctr"/>
-          <a:lstStyle/>
-          <a:p>
-            <a:pPr indent="0" marL="0">
-              <a:buNone/>
-            </a:pPr>
-            <a:r>
-              <a:rPr lang="en-US" sz="900" dirty="0">
+            <a:off x="594360" y="1696212"/>
+            <a:ext cx="4297680" cy="228600"/>
+          </a:xfrm>
+          <a:prstGeom prst="rect">
+            <a:avLst/>
+          </a:prstGeom>
+          <a:noFill/>
+          <a:ln/>
+        </p:spPr>
+        <p:txBody>
+          <a:bodyPr wrap="square" lIns="0" tIns="0" rIns="0" bIns="0" rtlCol="0" anchor="ctr"/>
+          <a:lstStyle/>
+          <a:p>
+            <a:pPr indent="0" marL="0">
+              <a:buNone/>
+            </a:pPr>
+            <a:r>
+              <a:rPr lang="en-US" sz="950" dirty="0">
                 <a:solidFill>
                   <a:srgbClr val="FFFFFF"/>
                 </a:solidFill>
@@ -8851,7 +8475,7 @@
               </a:rPr>
               <a:t>│   ├── ag_news_train.csv   (120k rows)</a:t>
             </a:r>
-            <a:endParaRPr lang="en-US" sz="900" dirty="0"/>
+            <a:endParaRPr lang="en-US" sz="950" dirty="0"/>
           </a:p>
         </p:txBody>
       </p:sp>
@@ -8863,24 +8487,24 @@
         </p:nvSpPr>
         <p:spPr>
           <a:xfrm>
-            <a:off x="594360" y="1792224"/>
-            <a:ext cx="4297680" cy="201168"/>
-          </a:xfrm>
-          <a:prstGeom prst="rect">
-            <a:avLst/>
-          </a:prstGeom>
-          <a:noFill/>
-          <a:ln/>
-        </p:spPr>
-        <p:txBody>
-          <a:bodyPr wrap="square" lIns="0" tIns="0" rIns="0" bIns="0" rtlCol="0" anchor="ctr"/>
-          <a:lstStyle/>
-          <a:p>
-            <a:pPr indent="0" marL="0">
-              <a:buNone/>
-            </a:pPr>
-            <a:r>
-              <a:rPr lang="en-US" sz="900" dirty="0">
+            <a:off x="594360" y="1920240"/>
+            <a:ext cx="4297680" cy="228600"/>
+          </a:xfrm>
+          <a:prstGeom prst="rect">
+            <a:avLst/>
+          </a:prstGeom>
+          <a:noFill/>
+          <a:ln/>
+        </p:spPr>
+        <p:txBody>
+          <a:bodyPr wrap="square" lIns="0" tIns="0" rIns="0" bIns="0" rtlCol="0" anchor="ctr"/>
+          <a:lstStyle/>
+          <a:p>
+            <a:pPr indent="0" marL="0">
+              <a:buNone/>
+            </a:pPr>
+            <a:r>
+              <a:rPr lang="en-US" sz="950" dirty="0">
                 <a:solidFill>
                   <a:srgbClr val="FFFFFF"/>
                 </a:solidFill>
@@ -8890,7 +8514,7 @@
               </a:rPr>
               <a:t>│   └── ag_news_test.csv    (7.6k rows)</a:t>
             </a:r>
-            <a:endParaRPr lang="en-US" sz="900" dirty="0"/>
+            <a:endParaRPr lang="en-US" sz="950" dirty="0"/>
           </a:p>
         </p:txBody>
       </p:sp>
@@ -8902,24 +8526,24 @@
         </p:nvSpPr>
         <p:spPr>
           <a:xfrm>
-            <a:off x="594360" y="1988820"/>
-            <a:ext cx="4297680" cy="201168"/>
-          </a:xfrm>
-          <a:prstGeom prst="rect">
-            <a:avLst/>
-          </a:prstGeom>
-          <a:noFill/>
-          <a:ln/>
-        </p:spPr>
-        <p:txBody>
-          <a:bodyPr wrap="square" lIns="0" tIns="0" rIns="0" bIns="0" rtlCol="0" anchor="ctr"/>
-          <a:lstStyle/>
-          <a:p>
-            <a:pPr indent="0" marL="0">
-              <a:buNone/>
-            </a:pPr>
-            <a:r>
-              <a:rPr lang="en-US" sz="900" dirty="0">
+            <a:off x="594360" y="2144268"/>
+            <a:ext cx="4297680" cy="228600"/>
+          </a:xfrm>
+          <a:prstGeom prst="rect">
+            <a:avLst/>
+          </a:prstGeom>
+          <a:noFill/>
+          <a:ln/>
+        </p:spPr>
+        <p:txBody>
+          <a:bodyPr wrap="square" lIns="0" tIns="0" rIns="0" bIns="0" rtlCol="0" anchor="ctr"/>
+          <a:lstStyle/>
+          <a:p>
+            <a:pPr indent="0" marL="0">
+              <a:buNone/>
+            </a:pPr>
+            <a:r>
+              <a:rPr lang="en-US" sz="950" dirty="0">
                 <a:solidFill>
                   <a:srgbClr val="90CAF9"/>
                 </a:solidFill>
@@ -8929,7 +8553,7 @@
               </a:rPr>
               <a:t>└── processed/</a:t>
             </a:r>
-            <a:endParaRPr lang="en-US" sz="900" dirty="0"/>
+            <a:endParaRPr lang="en-US" sz="950" dirty="0"/>
           </a:p>
         </p:txBody>
       </p:sp>
@@ -8941,24 +8565,24 @@
         </p:nvSpPr>
         <p:spPr>
           <a:xfrm>
-            <a:off x="594360" y="2185416"/>
-            <a:ext cx="4297680" cy="201168"/>
-          </a:xfrm>
-          <a:prstGeom prst="rect">
-            <a:avLst/>
-          </a:prstGeom>
-          <a:noFill/>
-          <a:ln/>
-        </p:spPr>
-        <p:txBody>
-          <a:bodyPr wrap="square" lIns="0" tIns="0" rIns="0" bIns="0" rtlCol="0" anchor="ctr"/>
-          <a:lstStyle/>
-          <a:p>
-            <a:pPr indent="0" marL="0">
-              <a:buNone/>
-            </a:pPr>
-            <a:r>
-              <a:rPr lang="en-US" sz="900" dirty="0">
+            <a:off x="594360" y="2368296"/>
+            <a:ext cx="4297680" cy="228600"/>
+          </a:xfrm>
+          <a:prstGeom prst="rect">
+            <a:avLst/>
+          </a:prstGeom>
+          <a:noFill/>
+          <a:ln/>
+        </p:spPr>
+        <p:txBody>
+          <a:bodyPr wrap="square" lIns="0" tIns="0" rIns="0" bIns="0" rtlCol="0" anchor="ctr"/>
+          <a:lstStyle/>
+          <a:p>
+            <a:pPr indent="0" marL="0">
+              <a:buNone/>
+            </a:pPr>
+            <a:r>
+              <a:rPr lang="en-US" sz="950" dirty="0">
                 <a:solidFill>
                   <a:srgbClr val="A5D6A7"/>
                 </a:solidFill>
@@ -8968,7 +8592,7 @@
               </a:rPr>
               <a:t>    ├── bbc/</a:t>
             </a:r>
-            <a:endParaRPr lang="en-US" sz="900" dirty="0"/>
+            <a:endParaRPr lang="en-US" sz="950" dirty="0"/>
           </a:p>
         </p:txBody>
       </p:sp>
@@ -8980,24 +8604,24 @@
         </p:nvSpPr>
         <p:spPr>
           <a:xfrm>
-            <a:off x="594360" y="2382012"/>
-            <a:ext cx="4297680" cy="201168"/>
-          </a:xfrm>
-          <a:prstGeom prst="rect">
-            <a:avLst/>
-          </a:prstGeom>
-          <a:noFill/>
-          <a:ln/>
-        </p:spPr>
-        <p:txBody>
-          <a:bodyPr wrap="square" lIns="0" tIns="0" rIns="0" bIns="0" rtlCol="0" anchor="ctr"/>
-          <a:lstStyle/>
-          <a:p>
-            <a:pPr indent="0" marL="0">
-              <a:buNone/>
-            </a:pPr>
-            <a:r>
-              <a:rPr lang="en-US" sz="900" dirty="0">
+            <a:off x="594360" y="2592324"/>
+            <a:ext cx="4297680" cy="228600"/>
+          </a:xfrm>
+          <a:prstGeom prst="rect">
+            <a:avLst/>
+          </a:prstGeom>
+          <a:noFill/>
+          <a:ln/>
+        </p:spPr>
+        <p:txBody>
+          <a:bodyPr wrap="square" lIns="0" tIns="0" rIns="0" bIns="0" rtlCol="0" anchor="ctr"/>
+          <a:lstStyle/>
+          <a:p>
+            <a:pPr indent="0" marL="0">
+              <a:buNone/>
+            </a:pPr>
+            <a:r>
+              <a:rPr lang="en-US" sz="950" dirty="0">
                 <a:solidFill>
                   <a:srgbClr val="FFFFFF"/>
                 </a:solidFill>
@@ -9007,7 +8631,7 @@
               </a:rPr>
               <a:t>    │   ├── train / val / test / debug</a:t>
             </a:r>
-            <a:endParaRPr lang="en-US" sz="900" dirty="0"/>
+            <a:endParaRPr lang="en-US" sz="950" dirty="0"/>
           </a:p>
         </p:txBody>
       </p:sp>
@@ -9019,24 +8643,24 @@
         </p:nvSpPr>
         <p:spPr>
           <a:xfrm>
-            <a:off x="594360" y="2578608"/>
-            <a:ext cx="4297680" cy="201168"/>
-          </a:xfrm>
-          <a:prstGeom prst="rect">
-            <a:avLst/>
-          </a:prstGeom>
-          <a:noFill/>
-          <a:ln/>
-        </p:spPr>
-        <p:txBody>
-          <a:bodyPr wrap="square" lIns="0" tIns="0" rIns="0" bIns="0" rtlCol="0" anchor="ctr"/>
-          <a:lstStyle/>
-          <a:p>
-            <a:pPr indent="0" marL="0">
-              <a:buNone/>
-            </a:pPr>
-            <a:r>
-              <a:rPr lang="en-US" sz="900" dirty="0">
+            <a:off x="594360" y="2816352"/>
+            <a:ext cx="4297680" cy="228600"/>
+          </a:xfrm>
+          <a:prstGeom prst="rect">
+            <a:avLst/>
+          </a:prstGeom>
+          <a:noFill/>
+          <a:ln/>
+        </p:spPr>
+        <p:txBody>
+          <a:bodyPr wrap="square" lIns="0" tIns="0" rIns="0" bIns="0" rtlCol="0" anchor="ctr"/>
+          <a:lstStyle/>
+          <a:p>
+            <a:pPr indent="0" marL="0">
+              <a:buNone/>
+            </a:pPr>
+            <a:r>
+              <a:rPr lang="en-US" sz="950" dirty="0">
                 <a:solidFill>
                   <a:srgbClr val="FFD180"/>
                 </a:solidFill>
@@ -9046,7 +8670,7 @@
               </a:rPr>
               <a:t>    └── agnews/</a:t>
             </a:r>
-            <a:endParaRPr lang="en-US" sz="900" dirty="0"/>
+            <a:endParaRPr lang="en-US" sz="950" dirty="0"/>
           </a:p>
         </p:txBody>
       </p:sp>
@@ -9058,24 +8682,24 @@
         </p:nvSpPr>
         <p:spPr>
           <a:xfrm>
-            <a:off x="594360" y="2775204"/>
-            <a:ext cx="4297680" cy="201168"/>
-          </a:xfrm>
-          <a:prstGeom prst="rect">
-            <a:avLst/>
-          </a:prstGeom>
-          <a:noFill/>
-          <a:ln/>
-        </p:spPr>
-        <p:txBody>
-          <a:bodyPr wrap="square" lIns="0" tIns="0" rIns="0" bIns="0" rtlCol="0" anchor="ctr"/>
-          <a:lstStyle/>
-          <a:p>
-            <a:pPr indent="0" marL="0">
-              <a:buNone/>
-            </a:pPr>
-            <a:r>
-              <a:rPr lang="en-US" sz="900" dirty="0">
+            <a:off x="594360" y="3040380"/>
+            <a:ext cx="4297680" cy="228600"/>
+          </a:xfrm>
+          <a:prstGeom prst="rect">
+            <a:avLst/>
+          </a:prstGeom>
+          <a:noFill/>
+          <a:ln/>
+        </p:spPr>
+        <p:txBody>
+          <a:bodyPr wrap="square" lIns="0" tIns="0" rIns="0" bIns="0" rtlCol="0" anchor="ctr"/>
+          <a:lstStyle/>
+          <a:p>
+            <a:pPr indent="0" marL="0">
+              <a:buNone/>
+            </a:pPr>
+            <a:r>
+              <a:rPr lang="en-US" sz="950" dirty="0">
                 <a:solidFill>
                   <a:srgbClr val="FFFFFF"/>
                 </a:solidFill>
@@ -9085,7 +8709,7 @@
               </a:rPr>
               <a:t>        ├── train.csv   (102,000 rows)</a:t>
             </a:r>
-            <a:endParaRPr lang="en-US" sz="900" dirty="0"/>
+            <a:endParaRPr lang="en-US" sz="950" dirty="0"/>
           </a:p>
         </p:txBody>
       </p:sp>
@@ -9097,24 +8721,24 @@
         </p:nvSpPr>
         <p:spPr>
           <a:xfrm>
-            <a:off x="594360" y="2971800"/>
-            <a:ext cx="4297680" cy="201168"/>
-          </a:xfrm>
-          <a:prstGeom prst="rect">
-            <a:avLst/>
-          </a:prstGeom>
-          <a:noFill/>
-          <a:ln/>
-        </p:spPr>
-        <p:txBody>
-          <a:bodyPr wrap="square" lIns="0" tIns="0" rIns="0" bIns="0" rtlCol="0" anchor="ctr"/>
-          <a:lstStyle/>
-          <a:p>
-            <a:pPr indent="0" marL="0">
-              <a:buNone/>
-            </a:pPr>
-            <a:r>
-              <a:rPr lang="en-US" sz="900" dirty="0">
+            <a:off x="594360" y="3264408"/>
+            <a:ext cx="4297680" cy="228600"/>
+          </a:xfrm>
+          <a:prstGeom prst="rect">
+            <a:avLst/>
+          </a:prstGeom>
+          <a:noFill/>
+          <a:ln/>
+        </p:spPr>
+        <p:txBody>
+          <a:bodyPr wrap="square" lIns="0" tIns="0" rIns="0" bIns="0" rtlCol="0" anchor="ctr"/>
+          <a:lstStyle/>
+          <a:p>
+            <a:pPr indent="0" marL="0">
+              <a:buNone/>
+            </a:pPr>
+            <a:r>
+              <a:rPr lang="en-US" sz="950" dirty="0">
                 <a:solidFill>
                   <a:srgbClr val="FFFFFF"/>
                 </a:solidFill>
@@ -9124,7 +8748,7 @@
               </a:rPr>
               <a:t>        ├── val.csv     ( 18,000 rows)</a:t>
             </a:r>
-            <a:endParaRPr lang="en-US" sz="900" dirty="0"/>
+            <a:endParaRPr lang="en-US" sz="950" dirty="0"/>
           </a:p>
         </p:txBody>
       </p:sp>
@@ -9136,24 +8760,24 @@
         </p:nvSpPr>
         <p:spPr>
           <a:xfrm>
-            <a:off x="594360" y="3168396"/>
-            <a:ext cx="4297680" cy="201168"/>
-          </a:xfrm>
-          <a:prstGeom prst="rect">
-            <a:avLst/>
-          </a:prstGeom>
-          <a:noFill/>
-          <a:ln/>
-        </p:spPr>
-        <p:txBody>
-          <a:bodyPr wrap="square" lIns="0" tIns="0" rIns="0" bIns="0" rtlCol="0" anchor="ctr"/>
-          <a:lstStyle/>
-          <a:p>
-            <a:pPr indent="0" marL="0">
-              <a:buNone/>
-            </a:pPr>
-            <a:r>
-              <a:rPr lang="en-US" sz="900" dirty="0">
+            <a:off x="594360" y="3488436"/>
+            <a:ext cx="4297680" cy="228600"/>
+          </a:xfrm>
+          <a:prstGeom prst="rect">
+            <a:avLst/>
+          </a:prstGeom>
+          <a:noFill/>
+          <a:ln/>
+        </p:spPr>
+        <p:txBody>
+          <a:bodyPr wrap="square" lIns="0" tIns="0" rIns="0" bIns="0" rtlCol="0" anchor="ctr"/>
+          <a:lstStyle/>
+          <a:p>
+            <a:pPr indent="0" marL="0">
+              <a:buNone/>
+            </a:pPr>
+            <a:r>
+              <a:rPr lang="en-US" sz="950" dirty="0">
                 <a:solidFill>
                   <a:srgbClr val="FFFFFF"/>
                 </a:solidFill>
@@ -9163,7 +8787,7 @@
               </a:rPr>
               <a:t>        ├── test.csv    (  7,600 rows)</a:t>
             </a:r>
-            <a:endParaRPr lang="en-US" sz="900" dirty="0"/>
+            <a:endParaRPr lang="en-US" sz="950" dirty="0"/>
           </a:p>
         </p:txBody>
       </p:sp>
@@ -9175,24 +8799,24 @@
         </p:nvSpPr>
         <p:spPr>
           <a:xfrm>
-            <a:off x="594360" y="3364992"/>
-            <a:ext cx="4297680" cy="201168"/>
-          </a:xfrm>
-          <a:prstGeom prst="rect">
-            <a:avLst/>
-          </a:prstGeom>
-          <a:noFill/>
-          <a:ln/>
-        </p:spPr>
-        <p:txBody>
-          <a:bodyPr wrap="square" lIns="0" tIns="0" rIns="0" bIns="0" rtlCol="0" anchor="ctr"/>
-          <a:lstStyle/>
-          <a:p>
-            <a:pPr indent="0" marL="0">
-              <a:buNone/>
-            </a:pPr>
-            <a:r>
-              <a:rPr lang="en-US" sz="900" dirty="0">
+            <a:off x="594360" y="3712464"/>
+            <a:ext cx="4297680" cy="228600"/>
+          </a:xfrm>
+          <a:prstGeom prst="rect">
+            <a:avLst/>
+          </a:prstGeom>
+          <a:noFill/>
+          <a:ln/>
+        </p:spPr>
+        <p:txBody>
+          <a:bodyPr wrap="square" lIns="0" tIns="0" rIns="0" bIns="0" rtlCol="0" anchor="ctr"/>
+          <a:lstStyle/>
+          <a:p>
+            <a:pPr indent="0" marL="0">
+              <a:buNone/>
+            </a:pPr>
+            <a:r>
+              <a:rPr lang="en-US" sz="950" dirty="0">
                 <a:solidFill>
                   <a:srgbClr val="FFFFFF"/>
                 </a:solidFill>
@@ -9202,7 +8826,7 @@
               </a:rPr>
               <a:t>        └── debug.csv   (     40 rows)</a:t>
             </a:r>
-            <a:endParaRPr lang="en-US" sz="900" dirty="0"/>
+            <a:endParaRPr lang="en-US" sz="950" dirty="0"/>
           </a:p>
         </p:txBody>
       </p:sp>
@@ -9215,7 +8839,7 @@
         <p:spPr>
           <a:xfrm>
             <a:off x="5212080" y="960120"/>
-            <a:ext cx="3474720" cy="1078992"/>
+            <a:ext cx="3474720" cy="1188720"/>
           </a:xfrm>
           <a:prstGeom prst="rect">
             <a:avLst/>
@@ -9308,7 +8932,7 @@
         <p:spPr>
           <a:xfrm>
             <a:off x="5349240" y="1399032"/>
-            <a:ext cx="3200400" cy="594360"/>
+            <a:ext cx="3200400" cy="704088"/>
           </a:xfrm>
           <a:prstGeom prst="rect">
             <a:avLst/>
@@ -9343,8 +8967,8 @@
         </p:nvSpPr>
         <p:spPr>
           <a:xfrm>
-            <a:off x="5212080" y="2167128"/>
-            <a:ext cx="3474720" cy="1078992"/>
+            <a:off x="5212080" y="2267712"/>
+            <a:ext cx="3474720" cy="1188720"/>
           </a:xfrm>
           <a:prstGeom prst="rect">
             <a:avLst/>
@@ -9375,7 +8999,7 @@
         </p:nvSpPr>
         <p:spPr>
           <a:xfrm>
-            <a:off x="5212080" y="2167128"/>
+            <a:off x="5212080" y="2267712"/>
             <a:ext cx="2743200" cy="347472"/>
           </a:xfrm>
           <a:prstGeom prst="rect">
@@ -9400,7 +9024,7 @@
         </p:nvSpPr>
         <p:spPr>
           <a:xfrm>
-            <a:off x="5212080" y="2167128"/>
+            <a:off x="5212080" y="2267712"/>
             <a:ext cx="2743200" cy="347472"/>
           </a:xfrm>
           <a:prstGeom prst="rect">
@@ -9436,8 +9060,8 @@
         </p:nvSpPr>
         <p:spPr>
           <a:xfrm>
-            <a:off x="5349240" y="2606040"/>
-            <a:ext cx="3200400" cy="594360"/>
+            <a:off x="5349240" y="2706624"/>
+            <a:ext cx="3200400" cy="704088"/>
           </a:xfrm>
           <a:prstGeom prst="rect">
             <a:avLst/>
@@ -9472,8 +9096,8 @@
         </p:nvSpPr>
         <p:spPr>
           <a:xfrm>
-            <a:off x="5212080" y="3374136"/>
-            <a:ext cx="3474720" cy="1078992"/>
+            <a:off x="5212080" y="3575304"/>
+            <a:ext cx="3474720" cy="1188720"/>
           </a:xfrm>
           <a:prstGeom prst="rect">
             <a:avLst/>
@@ -9504,7 +9128,7 @@
         </p:nvSpPr>
         <p:spPr>
           <a:xfrm>
-            <a:off x="5212080" y="3374136"/>
+            <a:off x="5212080" y="3575304"/>
             <a:ext cx="2743200" cy="347472"/>
           </a:xfrm>
           <a:prstGeom prst="rect">
@@ -9529,7 +9153,7 @@
         </p:nvSpPr>
         <p:spPr>
           <a:xfrm>
-            <a:off x="5212080" y="3374136"/>
+            <a:off x="5212080" y="3575304"/>
             <a:ext cx="2743200" cy="347472"/>
           </a:xfrm>
           <a:prstGeom prst="rect">
@@ -9565,8 +9189,8 @@
         </p:nvSpPr>
         <p:spPr>
           <a:xfrm>
-            <a:off x="5349240" y="3813048"/>
-            <a:ext cx="3200400" cy="594360"/>
+            <a:off x="5349240" y="4014216"/>
+            <a:ext cx="3200400" cy="704088"/>
           </a:xfrm>
           <a:prstGeom prst="rect">
             <a:avLst/>
@@ -9587,277 +9211,9 @@
                   <a:srgbClr val="4A4A4A"/>
                 </a:solidFill>
               </a:rPr>
-              <a:t>40 rows (AG News) and 50 rows (BBC) — 10 per class — for fast smoke-testing without a full training run.</a:t>
+              <a:t>40 rows (AG News) and 50 rows (BBC) — 10 per class — for fast smoke-testing.</a:t>
             </a:r>
             <a:endParaRPr lang="en-US" sz="1100" dirty="0"/>
-          </a:p>
-        </p:txBody>
-      </p:sp>
-      <p:sp>
-        <p:nvSpPr>
-          <p:cNvPr id="29" name="Shape 27"/>
-          <p:cNvSpPr/>
-          <p:nvPr/>
-        </p:nvSpPr>
-        <p:spPr>
-          <a:xfrm>
-            <a:off x="0" y="4818888"/>
-            <a:ext cx="9144000" cy="324612"/>
-          </a:xfrm>
-          <a:prstGeom prst="rect">
-            <a:avLst/>
-          </a:prstGeom>
-          <a:solidFill>
-            <a:srgbClr val="1A1A1A"/>
-          </a:solidFill>
-          <a:ln w="12700">
-            <a:solidFill>
-              <a:srgbClr val="1A1A1A"/>
-            </a:solidFill>
-            <a:prstDash val="solid"/>
-          </a:ln>
-        </p:spPr>
-      </p:sp>
-      <p:sp>
-        <p:nvSpPr>
-          <p:cNvPr id="30" name="Text 28"/>
-          <p:cNvSpPr/>
-          <p:nvPr/>
-        </p:nvSpPr>
-        <p:spPr>
-          <a:xfrm>
-            <a:off x="274320" y="4828032"/>
-            <a:ext cx="8595360" cy="301752"/>
-          </a:xfrm>
-          <a:prstGeom prst="rect">
-            <a:avLst/>
-          </a:prstGeom>
-          <a:noFill/>
-          <a:ln/>
-        </p:spPr>
-        <p:txBody>
-          <a:bodyPr wrap="square" lIns="0" tIns="0" rIns="0" bIns="0" rtlCol="0" anchor="ctr"/>
-          <a:lstStyle/>
-          <a:p>
-            <a:pPr algn="l" indent="0" marL="0">
-              <a:buNone/>
-            </a:pPr>
-            <a:r>
-              <a:rPr lang="en-US" sz="900" dirty="0">
-                <a:solidFill>
-                  <a:srgbClr val="AAAAAA"/>
-                </a:solidFill>
-              </a:rPr>
-              <a:t>Ming-Hsiang Lee  ·  Data Pipeline &amp; Preprocessing  ·  News Topic Classification  ·  Group 2</a:t>
-            </a:r>
-            <a:endParaRPr lang="en-US" sz="900" dirty="0"/>
-          </a:p>
-        </p:txBody>
-      </p:sp>
-    </p:spTree>
-  </p:cSld>
-  <p:clrMapOvr>
-    <a:masterClrMapping/>
-  </p:clrMapOvr>
-</p:sld>
-</file>
-
-<file path=ppt/slides/slide9.xml><?xml version="1.0" encoding="utf-8"?>
-<p:sld xmlns:a="http://schemas.openxmlformats.org/drawingml/2006/main" xmlns:r="http://schemas.openxmlformats.org/officeDocument/2006/relationships" xmlns:p="http://schemas.openxmlformats.org/presentationml/2006/main">
-  <p:cSld name="Slide 9">
-    <p:bg>
-      <p:bgPr>
-        <a:solidFill>
-          <a:srgbClr val="F5F0E8"/>
-        </a:solidFill>
-      </p:bgPr>
-    </p:bg>
-    <p:spTree>
-      <p:nvGrpSpPr>
-        <p:cNvPr id="1" name=""/>
-        <p:cNvGrpSpPr/>
-        <p:nvPr/>
-      </p:nvGrpSpPr>
-      <p:grpSpPr>
-        <a:xfrm>
-          <a:off x="0" y="0"/>
-          <a:ext cx="0" cy="0"/>
-          <a:chOff x="0" y="0"/>
-          <a:chExt cx="0" cy="0"/>
-        </a:xfrm>
-      </p:grpSpPr>
-      <p:sp>
-        <p:nvSpPr>
-          <p:cNvPr id="2" name="Text 0"/>
-          <p:cNvSpPr/>
-          <p:nvPr/>
-        </p:nvSpPr>
-        <p:spPr>
-          <a:xfrm>
-            <a:off x="457200" y="1188720"/>
-            <a:ext cx="8229600" cy="1828800"/>
-          </a:xfrm>
-          <a:prstGeom prst="rect">
-            <a:avLst/>
-          </a:prstGeom>
-          <a:noFill/>
-          <a:ln/>
-        </p:spPr>
-        <p:txBody>
-          <a:bodyPr wrap="square" rtlCol="0" anchor="ctr"/>
-          <a:lstStyle/>
-          <a:p>
-            <a:pPr algn="ctr" indent="0" marL="0">
-              <a:buNone/>
-            </a:pPr>
-            <a:r>
-              <a:rPr lang="en-US" sz="7200" b="1" dirty="0">
-                <a:solidFill>
-                  <a:srgbClr val="1A1A1A"/>
-                </a:solidFill>
-                <a:latin typeface="Arial Black" pitchFamily="34" charset="0"/>
-                <a:ea typeface="Arial Black" pitchFamily="34" charset="-122"/>
-                <a:cs typeface="Arial Black" pitchFamily="34" charset="-120"/>
-              </a:rPr>
-              <a:t>Thank You</a:t>
-            </a:r>
-            <a:endParaRPr lang="en-US" sz="7200" dirty="0"/>
-          </a:p>
-        </p:txBody>
-      </p:sp>
-      <p:sp>
-        <p:nvSpPr>
-          <p:cNvPr id="3" name="Shape 1"/>
-          <p:cNvSpPr/>
-          <p:nvPr/>
-        </p:nvSpPr>
-        <p:spPr>
-          <a:xfrm>
-            <a:off x="0" y="4251960"/>
-            <a:ext cx="9144000" cy="891540"/>
-          </a:xfrm>
-          <a:prstGeom prst="rect">
-            <a:avLst/>
-          </a:prstGeom>
-          <a:solidFill>
-            <a:srgbClr val="1A1A1A"/>
-          </a:solidFill>
-          <a:ln w="12700">
-            <a:solidFill>
-              <a:srgbClr val="1A1A1A"/>
-            </a:solidFill>
-            <a:prstDash val="solid"/>
-          </a:ln>
-        </p:spPr>
-      </p:sp>
-      <p:sp>
-        <p:nvSpPr>
-          <p:cNvPr id="4" name="Text 2"/>
-          <p:cNvSpPr/>
-          <p:nvPr/>
-        </p:nvSpPr>
-        <p:spPr>
-          <a:xfrm>
-            <a:off x="457200" y="4315968"/>
-            <a:ext cx="1828800" cy="365760"/>
-          </a:xfrm>
-          <a:prstGeom prst="rect">
-            <a:avLst/>
-          </a:prstGeom>
-          <a:noFill/>
-          <a:ln/>
-        </p:spPr>
-        <p:txBody>
-          <a:bodyPr wrap="square" lIns="0" tIns="0" rIns="0" bIns="0" rtlCol="0" anchor="ctr"/>
-          <a:lstStyle/>
-          <a:p>
-            <a:pPr algn="l" indent="0" marL="0">
-              <a:buNone/>
-            </a:pPr>
-            <a:r>
-              <a:rPr lang="en-US" sz="1400" b="1" dirty="0">
-                <a:solidFill>
-                  <a:srgbClr val="FFFFFF"/>
-                </a:solidFill>
-              </a:rPr>
-              <a:t>Group 2</a:t>
-            </a:r>
-            <a:endParaRPr lang="en-US" sz="1400" dirty="0"/>
-          </a:p>
-        </p:txBody>
-      </p:sp>
-      <p:sp>
-        <p:nvSpPr>
-          <p:cNvPr id="5" name="Text 3"/>
-          <p:cNvSpPr/>
-          <p:nvPr/>
-        </p:nvSpPr>
-        <p:spPr>
-          <a:xfrm>
-            <a:off x="457200" y="4663440"/>
-            <a:ext cx="4572000" cy="256032"/>
-          </a:xfrm>
-          <a:prstGeom prst="rect">
-            <a:avLst/>
-          </a:prstGeom>
-          <a:noFill/>
-          <a:ln/>
-        </p:spPr>
-        <p:txBody>
-          <a:bodyPr wrap="square" lIns="0" tIns="0" rIns="0" bIns="0" rtlCol="0" anchor="ctr"/>
-          <a:lstStyle/>
-          <a:p>
-            <a:pPr algn="l" indent="0" marL="0">
-              <a:buNone/>
-            </a:pPr>
-            <a:r>
-              <a:rPr lang="en-US" sz="1000" dirty="0">
-                <a:solidFill>
-                  <a:srgbClr val="AAAAAA"/>
-                </a:solidFill>
-              </a:rPr>
-              <a:t>Ming-Hsiang Lee  ·  lee.minghsi@northeastern.edu</a:t>
-            </a:r>
-            <a:endParaRPr lang="en-US" sz="1000" dirty="0"/>
-          </a:p>
-        </p:txBody>
-      </p:sp>
-      <p:sp>
-        <p:nvSpPr>
-          <p:cNvPr id="6" name="Text 4"/>
-          <p:cNvSpPr/>
-          <p:nvPr/>
-        </p:nvSpPr>
-        <p:spPr>
-          <a:xfrm>
-            <a:off x="3200400" y="4315968"/>
-            <a:ext cx="5669280" cy="777240"/>
-          </a:xfrm>
-          <a:prstGeom prst="rect">
-            <a:avLst/>
-          </a:prstGeom>
-          <a:noFill/>
-          <a:ln/>
-        </p:spPr>
-        <p:txBody>
-          <a:bodyPr wrap="square" lIns="0" tIns="0" rIns="0" bIns="0" rtlCol="0" anchor="ctr"/>
-          <a:lstStyle/>
-          <a:p>
-            <a:pPr algn="r" indent="0" marL="0">
-              <a:buNone/>
-            </a:pPr>
-            <a:r>
-              <a:rPr lang="en-US" sz="1000" dirty="0">
-                <a:solidFill>
-                  <a:srgbClr val="AAAAAA"/>
-                </a:solidFill>
-                <a:latin typeface="Consolas" pitchFamily="34" charset="0"/>
-                <a:ea typeface="Consolas" pitchFamily="34" charset="-122"/>
-                <a:cs typeface="Consolas" pitchFamily="34" charset="-120"/>
-              </a:rPr>
-              <a:t>src/download_data.py  ·  src/data_preprocessing.py  ·  data/processed/</a:t>
-            </a:r>
-            <a:endParaRPr lang="en-US" sz="1000" dirty="0"/>
           </a:p>
         </p:txBody>
       </p:sp>

</xml_diff>